<commit_message>
Update public portfolio assets and streamline AWS experience
</commit_message>
<xml_diff>
--- a/public/assets/value-predictor-slides.pptx
+++ b/public/assets/value-predictor-slides.pptx
@@ -4,9 +4,6 @@
   <p:sldMasterIdLst>
     <p:sldMasterId id="2147483648" r:id="rId4"/>
   </p:sldMasterIdLst>
-  <p:notesMasterIdLst>
-    <p:notesMasterId r:id="rId5"/>
-  </p:notesMasterIdLst>
   <p:sldIdLst>
     <p:sldId id="256" r:id="rId6"/>
     <p:sldId id="257" r:id="rId7"/>
@@ -268,4117 +265,6 @@
     </p:ext>
   </p:extLst>
 </p:presentation>
-</file>
-
-<file path=ppt/commentAuthors.xml><?xml version="1.0" encoding="utf-8"?>
-<p:cmAuthorLst xmlns:a="http://schemas.openxmlformats.org/drawingml/2006/main" xmlns:r="http://schemas.openxmlformats.org/officeDocument/2006/relationships" xmlns:mc="http://schemas.openxmlformats.org/markup-compatibility/2006" xmlns:mv="urn:schemas-microsoft-com:mac:vml" xmlns:p="http://schemas.openxmlformats.org/presentationml/2006/main" xmlns:c="http://schemas.openxmlformats.org/drawingml/2006/chart" xmlns:dgm="http://schemas.openxmlformats.org/drawingml/2006/diagram" xmlns:o="urn:schemas-microsoft-com:office:office" xmlns:v="urn:schemas-microsoft-com:vml" xmlns:pvml="urn:schemas-microsoft-com:office:powerpoint" xmlns:com="http://schemas.openxmlformats.org/drawingml/2006/compatibility" xmlns:p14="http://schemas.microsoft.com/office/powerpoint/2010/main" xmlns:p15="http://schemas.microsoft.com/office/powerpoint/2012/main" xmlns:ahyp="http://schemas.microsoft.com/office/drawing/2018/hyperlinkcolor">
-  <p:cmAuthor clrIdx="0" id="0" initials="" lastIdx="1" name="Aadesh Shah"/>
-</p:cmAuthorLst>
-</file>
-
-<file path=ppt/comments/comment1.xml><?xml version="1.0" encoding="utf-8"?>
-<p:cmLst xmlns:a="http://schemas.openxmlformats.org/drawingml/2006/main" xmlns:r="http://schemas.openxmlformats.org/officeDocument/2006/relationships" xmlns:mc="http://schemas.openxmlformats.org/markup-compatibility/2006" xmlns:mv="urn:schemas-microsoft-com:mac:vml" xmlns:p="http://schemas.openxmlformats.org/presentationml/2006/main" xmlns:c="http://schemas.openxmlformats.org/drawingml/2006/chart" xmlns:dgm="http://schemas.openxmlformats.org/drawingml/2006/diagram" xmlns:o="urn:schemas-microsoft-com:office:office" xmlns:v="urn:schemas-microsoft-com:vml" xmlns:pvml="urn:schemas-microsoft-com:office:powerpoint" xmlns:com="http://schemas.openxmlformats.org/drawingml/2006/compatibility" xmlns:p14="http://schemas.microsoft.com/office/powerpoint/2010/main" xmlns:p15="http://schemas.microsoft.com/office/powerpoint/2012/main" xmlns:ahyp="http://schemas.microsoft.com/office/drawing/2018/hyperlinkcolor">
-  <p:cm authorId="0" idx="1" dt="2026-04-23T17:37:08.061">
-    <p:pos x="230" y="46"/>
-    <p:text>When talking about this slide, we need to emphasize that we are comparing it to the example SVP-only configuration.</p:text>
-    <p:extLst>
-      <p:ext uri="{C676402C-5697-4E1C-873F-D02D1690AC5C}">
-        <p15:threadingInfo timeZoneBias="0"/>
-      </p:ext>
-      <p:ext uri="http://customooxmlschemas.google.com/">
-        <go:slidesCustomData xmlns:go="http://customooxmlschemas.google.com/" commentPostId="AAAB4jS42Fc"/>
-      </p:ext>
-    </p:extLst>
-  </p:cm>
-</p:cmLst>
-</file>
-
-<file path=ppt/notesMasters/notesMaster1.xml><?xml version="1.0" encoding="utf-8"?>
-<p:notesMaster xmlns:a="http://schemas.openxmlformats.org/drawingml/2006/main" xmlns:r="http://schemas.openxmlformats.org/officeDocument/2006/relationships" xmlns:mc="http://schemas.openxmlformats.org/markup-compatibility/2006" xmlns:mv="urn:schemas-microsoft-com:mac:vml" xmlns:p="http://schemas.openxmlformats.org/presentationml/2006/main" xmlns:c="http://schemas.openxmlformats.org/drawingml/2006/chart" xmlns:dgm="http://schemas.openxmlformats.org/drawingml/2006/diagram" xmlns:o="urn:schemas-microsoft-com:office:office" xmlns:v="urn:schemas-microsoft-com:vml" xmlns:pvml="urn:schemas-microsoft-com:office:powerpoint" xmlns:com="http://schemas.openxmlformats.org/drawingml/2006/compatibility" xmlns:p14="http://schemas.microsoft.com/office/powerpoint/2010/main" xmlns:p15="http://schemas.microsoft.com/office/powerpoint/2012/main" xmlns:ahyp="http://schemas.microsoft.com/office/drawing/2018/hyperlinkcolor">
-  <p:cSld>
-    <p:bg>
-      <p:bgPr>
-        <a:solidFill>
-          <a:schemeClr val="lt1"/>
-        </a:solidFill>
-      </p:bgPr>
-    </p:bg>
-    <p:spTree>
-      <p:nvGrpSpPr>
-        <p:cNvPr id="2" name="Shape 2"/>
-        <p:cNvGrpSpPr/>
-        <p:nvPr/>
-      </p:nvGrpSpPr>
-      <p:grpSpPr>
-        <a:xfrm>
-          <a:off x="0" y="0"/>
-          <a:ext cx="0" cy="0"/>
-          <a:chOff x="0" y="0"/>
-          <a:chExt cx="0" cy="0"/>
-        </a:xfrm>
-      </p:grpSpPr>
-      <p:sp>
-        <p:nvSpPr>
-          <p:cNvPr id="3" name="Google Shape;3;n"/>
-          <p:cNvSpPr/>
-          <p:nvPr>
-            <p:ph idx="2" type="sldImg"/>
-          </p:nvPr>
-        </p:nvSpPr>
-        <p:spPr>
-          <a:xfrm>
-            <a:off x="857400" y="685800"/>
-            <a:ext cx="3429150" cy="3429000"/>
-          </a:xfrm>
-          <a:custGeom>
-            <a:rect b="b" l="l" r="r" t="t"/>
-            <a:pathLst>
-              <a:path extrusionOk="0" h="120000" w="120000">
-                <a:moveTo>
-                  <a:pt x="0" y="0"/>
-                </a:moveTo>
-                <a:lnTo>
-                  <a:pt x="120000" y="0"/>
-                </a:lnTo>
-                <a:lnTo>
-                  <a:pt x="120000" y="120000"/>
-                </a:lnTo>
-                <a:lnTo>
-                  <a:pt x="0" y="120000"/>
-                </a:lnTo>
-                <a:close/>
-              </a:path>
-            </a:pathLst>
-          </a:custGeom>
-          <a:noFill/>
-          <a:ln cap="flat" cmpd="sng" w="9525">
-            <a:solidFill>
-              <a:srgbClr val="000000"/>
-            </a:solidFill>
-            <a:prstDash val="solid"/>
-            <a:round/>
-            <a:headEnd len="sm" w="sm" type="none"/>
-            <a:tailEnd len="sm" w="sm" type="none"/>
-          </a:ln>
-        </p:spPr>
-      </p:sp>
-      <p:sp>
-        <p:nvSpPr>
-          <p:cNvPr id="4" name="Google Shape;4;n"/>
-          <p:cNvSpPr txBox="1"/>
-          <p:nvPr>
-            <p:ph idx="1" type="body"/>
-          </p:nvPr>
-        </p:nvSpPr>
-        <p:spPr>
-          <a:xfrm>
-            <a:off x="514350" y="4343400"/>
-            <a:ext cx="4114800" cy="4114800"/>
-          </a:xfrm>
-          <a:prstGeom prst="rect">
-            <a:avLst/>
-          </a:prstGeom>
-          <a:noFill/>
-          <a:ln>
-            <a:noFill/>
-          </a:ln>
-        </p:spPr>
-        <p:txBody>
-          <a:bodyPr anchorCtr="0" anchor="t" bIns="91425" lIns="91425" spcFirstLastPara="1" rIns="91425" wrap="square" tIns="91425">
-            <a:noAutofit/>
-          </a:bodyPr>
-          <a:lstStyle>
-            <a:lvl1pPr indent="-298450" lvl="0" marL="457200">
-              <a:spcBef>
-                <a:spcPts val="0"/>
-              </a:spcBef>
-              <a:spcAft>
-                <a:spcPts val="0"/>
-              </a:spcAft>
-              <a:buSzPts val="1100"/>
-              <a:buChar char="●"/>
-              <a:defRPr sz="1100"/>
-            </a:lvl1pPr>
-            <a:lvl2pPr indent="-298450" lvl="1" marL="914400">
-              <a:spcBef>
-                <a:spcPts val="0"/>
-              </a:spcBef>
-              <a:spcAft>
-                <a:spcPts val="0"/>
-              </a:spcAft>
-              <a:buSzPts val="1100"/>
-              <a:buChar char="○"/>
-              <a:defRPr sz="1100"/>
-            </a:lvl2pPr>
-            <a:lvl3pPr indent="-298450" lvl="2" marL="1371600">
-              <a:spcBef>
-                <a:spcPts val="0"/>
-              </a:spcBef>
-              <a:spcAft>
-                <a:spcPts val="0"/>
-              </a:spcAft>
-              <a:buSzPts val="1100"/>
-              <a:buChar char="■"/>
-              <a:defRPr sz="1100"/>
-            </a:lvl3pPr>
-            <a:lvl4pPr indent="-298450" lvl="3" marL="1828800">
-              <a:spcBef>
-                <a:spcPts val="0"/>
-              </a:spcBef>
-              <a:spcAft>
-                <a:spcPts val="0"/>
-              </a:spcAft>
-              <a:buSzPts val="1100"/>
-              <a:buChar char="●"/>
-              <a:defRPr sz="1100"/>
-            </a:lvl4pPr>
-            <a:lvl5pPr indent="-298450" lvl="4" marL="2286000">
-              <a:spcBef>
-                <a:spcPts val="0"/>
-              </a:spcBef>
-              <a:spcAft>
-                <a:spcPts val="0"/>
-              </a:spcAft>
-              <a:buSzPts val="1100"/>
-              <a:buChar char="○"/>
-              <a:defRPr sz="1100"/>
-            </a:lvl5pPr>
-            <a:lvl6pPr indent="-298450" lvl="5" marL="2743200">
-              <a:spcBef>
-                <a:spcPts val="0"/>
-              </a:spcBef>
-              <a:spcAft>
-                <a:spcPts val="0"/>
-              </a:spcAft>
-              <a:buSzPts val="1100"/>
-              <a:buChar char="■"/>
-              <a:defRPr sz="1100"/>
-            </a:lvl6pPr>
-            <a:lvl7pPr indent="-298450" lvl="6" marL="3200400">
-              <a:spcBef>
-                <a:spcPts val="0"/>
-              </a:spcBef>
-              <a:spcAft>
-                <a:spcPts val="0"/>
-              </a:spcAft>
-              <a:buSzPts val="1100"/>
-              <a:buChar char="●"/>
-              <a:defRPr sz="1100"/>
-            </a:lvl7pPr>
-            <a:lvl8pPr indent="-298450" lvl="7" marL="3657600">
-              <a:spcBef>
-                <a:spcPts val="0"/>
-              </a:spcBef>
-              <a:spcAft>
-                <a:spcPts val="0"/>
-              </a:spcAft>
-              <a:buSzPts val="1100"/>
-              <a:buChar char="○"/>
-              <a:defRPr sz="1100"/>
-            </a:lvl8pPr>
-            <a:lvl9pPr indent="-298450" lvl="8" marL="4114800">
-              <a:spcBef>
-                <a:spcPts val="0"/>
-              </a:spcBef>
-              <a:spcAft>
-                <a:spcPts val="0"/>
-              </a:spcAft>
-              <a:buSzPts val="1100"/>
-              <a:buChar char="■"/>
-              <a:defRPr sz="1100"/>
-            </a:lvl9pPr>
-          </a:lstStyle>
-          <a:p/>
-        </p:txBody>
-      </p:sp>
-    </p:spTree>
-  </p:cSld>
-  <p:clrMap accent1="accent1" accent2="accent2" accent3="accent3" accent4="accent4" accent5="accent5" accent6="accent6" bg1="lt1" bg2="dk2" tx1="dk1" tx2="lt2" folHlink="folHlink" hlink="hlink"/>
-  <p:notesStyle>
-    <a:defPPr lvl="0" marR="0" rtl="0" algn="l">
-      <a:lnSpc>
-        <a:spcPct val="100000"/>
-      </a:lnSpc>
-      <a:spcBef>
-        <a:spcPts val="0"/>
-      </a:spcBef>
-      <a:spcAft>
-        <a:spcPts val="0"/>
-      </a:spcAft>
-    </a:defPPr>
-    <a:lvl1pPr lvl="0" marR="0" rtl="0" algn="l">
-      <a:lnSpc>
-        <a:spcPct val="100000"/>
-      </a:lnSpc>
-      <a:spcBef>
-        <a:spcPts val="0"/>
-      </a:spcBef>
-      <a:spcAft>
-        <a:spcPts val="0"/>
-      </a:spcAft>
-      <a:buClr>
-        <a:srgbClr val="000000"/>
-      </a:buClr>
-      <a:buFont typeface="Arial"/>
-      <a:defRPr b="0" i="0" sz="1400" u="none" cap="none" strike="noStrike">
-        <a:solidFill>
-          <a:srgbClr val="000000"/>
-        </a:solidFill>
-        <a:latin typeface="Arial"/>
-        <a:ea typeface="Arial"/>
-        <a:cs typeface="Arial"/>
-        <a:sym typeface="Arial"/>
-      </a:defRPr>
-    </a:lvl1pPr>
-    <a:lvl2pPr lvl="1" marR="0" rtl="0" algn="l">
-      <a:lnSpc>
-        <a:spcPct val="100000"/>
-      </a:lnSpc>
-      <a:spcBef>
-        <a:spcPts val="0"/>
-      </a:spcBef>
-      <a:spcAft>
-        <a:spcPts val="0"/>
-      </a:spcAft>
-      <a:buClr>
-        <a:srgbClr val="000000"/>
-      </a:buClr>
-      <a:buFont typeface="Arial"/>
-      <a:defRPr b="0" i="0" sz="1400" u="none" cap="none" strike="noStrike">
-        <a:solidFill>
-          <a:srgbClr val="000000"/>
-        </a:solidFill>
-        <a:latin typeface="Arial"/>
-        <a:ea typeface="Arial"/>
-        <a:cs typeface="Arial"/>
-        <a:sym typeface="Arial"/>
-      </a:defRPr>
-    </a:lvl2pPr>
-    <a:lvl3pPr lvl="2" marR="0" rtl="0" algn="l">
-      <a:lnSpc>
-        <a:spcPct val="100000"/>
-      </a:lnSpc>
-      <a:spcBef>
-        <a:spcPts val="0"/>
-      </a:spcBef>
-      <a:spcAft>
-        <a:spcPts val="0"/>
-      </a:spcAft>
-      <a:buClr>
-        <a:srgbClr val="000000"/>
-      </a:buClr>
-      <a:buFont typeface="Arial"/>
-      <a:defRPr b="0" i="0" sz="1400" u="none" cap="none" strike="noStrike">
-        <a:solidFill>
-          <a:srgbClr val="000000"/>
-        </a:solidFill>
-        <a:latin typeface="Arial"/>
-        <a:ea typeface="Arial"/>
-        <a:cs typeface="Arial"/>
-        <a:sym typeface="Arial"/>
-      </a:defRPr>
-    </a:lvl3pPr>
-    <a:lvl4pPr lvl="3" marR="0" rtl="0" algn="l">
-      <a:lnSpc>
-        <a:spcPct val="100000"/>
-      </a:lnSpc>
-      <a:spcBef>
-        <a:spcPts val="0"/>
-      </a:spcBef>
-      <a:spcAft>
-        <a:spcPts val="0"/>
-      </a:spcAft>
-      <a:buClr>
-        <a:srgbClr val="000000"/>
-      </a:buClr>
-      <a:buFont typeface="Arial"/>
-      <a:defRPr b="0" i="0" sz="1400" u="none" cap="none" strike="noStrike">
-        <a:solidFill>
-          <a:srgbClr val="000000"/>
-        </a:solidFill>
-        <a:latin typeface="Arial"/>
-        <a:ea typeface="Arial"/>
-        <a:cs typeface="Arial"/>
-        <a:sym typeface="Arial"/>
-      </a:defRPr>
-    </a:lvl4pPr>
-    <a:lvl5pPr lvl="4" marR="0" rtl="0" algn="l">
-      <a:lnSpc>
-        <a:spcPct val="100000"/>
-      </a:lnSpc>
-      <a:spcBef>
-        <a:spcPts val="0"/>
-      </a:spcBef>
-      <a:spcAft>
-        <a:spcPts val="0"/>
-      </a:spcAft>
-      <a:buClr>
-        <a:srgbClr val="000000"/>
-      </a:buClr>
-      <a:buFont typeface="Arial"/>
-      <a:defRPr b="0" i="0" sz="1400" u="none" cap="none" strike="noStrike">
-        <a:solidFill>
-          <a:srgbClr val="000000"/>
-        </a:solidFill>
-        <a:latin typeface="Arial"/>
-        <a:ea typeface="Arial"/>
-        <a:cs typeface="Arial"/>
-        <a:sym typeface="Arial"/>
-      </a:defRPr>
-    </a:lvl5pPr>
-    <a:lvl6pPr lvl="5" marR="0" rtl="0" algn="l">
-      <a:lnSpc>
-        <a:spcPct val="100000"/>
-      </a:lnSpc>
-      <a:spcBef>
-        <a:spcPts val="0"/>
-      </a:spcBef>
-      <a:spcAft>
-        <a:spcPts val="0"/>
-      </a:spcAft>
-      <a:buClr>
-        <a:srgbClr val="000000"/>
-      </a:buClr>
-      <a:buFont typeface="Arial"/>
-      <a:defRPr b="0" i="0" sz="1400" u="none" cap="none" strike="noStrike">
-        <a:solidFill>
-          <a:srgbClr val="000000"/>
-        </a:solidFill>
-        <a:latin typeface="Arial"/>
-        <a:ea typeface="Arial"/>
-        <a:cs typeface="Arial"/>
-        <a:sym typeface="Arial"/>
-      </a:defRPr>
-    </a:lvl6pPr>
-    <a:lvl7pPr lvl="6" marR="0" rtl="0" algn="l">
-      <a:lnSpc>
-        <a:spcPct val="100000"/>
-      </a:lnSpc>
-      <a:spcBef>
-        <a:spcPts val="0"/>
-      </a:spcBef>
-      <a:spcAft>
-        <a:spcPts val="0"/>
-      </a:spcAft>
-      <a:buClr>
-        <a:srgbClr val="000000"/>
-      </a:buClr>
-      <a:buFont typeface="Arial"/>
-      <a:defRPr b="0" i="0" sz="1400" u="none" cap="none" strike="noStrike">
-        <a:solidFill>
-          <a:srgbClr val="000000"/>
-        </a:solidFill>
-        <a:latin typeface="Arial"/>
-        <a:ea typeface="Arial"/>
-        <a:cs typeface="Arial"/>
-        <a:sym typeface="Arial"/>
-      </a:defRPr>
-    </a:lvl7pPr>
-    <a:lvl8pPr lvl="7" marR="0" rtl="0" algn="l">
-      <a:lnSpc>
-        <a:spcPct val="100000"/>
-      </a:lnSpc>
-      <a:spcBef>
-        <a:spcPts val="0"/>
-      </a:spcBef>
-      <a:spcAft>
-        <a:spcPts val="0"/>
-      </a:spcAft>
-      <a:buClr>
-        <a:srgbClr val="000000"/>
-      </a:buClr>
-      <a:buFont typeface="Arial"/>
-      <a:defRPr b="0" i="0" sz="1400" u="none" cap="none" strike="noStrike">
-        <a:solidFill>
-          <a:srgbClr val="000000"/>
-        </a:solidFill>
-        <a:latin typeface="Arial"/>
-        <a:ea typeface="Arial"/>
-        <a:cs typeface="Arial"/>
-        <a:sym typeface="Arial"/>
-      </a:defRPr>
-    </a:lvl8pPr>
-    <a:lvl9pPr lvl="8" marR="0" rtl="0" algn="l">
-      <a:lnSpc>
-        <a:spcPct val="100000"/>
-      </a:lnSpc>
-      <a:spcBef>
-        <a:spcPts val="0"/>
-      </a:spcBef>
-      <a:spcAft>
-        <a:spcPts val="0"/>
-      </a:spcAft>
-      <a:buClr>
-        <a:srgbClr val="000000"/>
-      </a:buClr>
-      <a:buFont typeface="Arial"/>
-      <a:defRPr b="0" i="0" sz="1400" u="none" cap="none" strike="noStrike">
-        <a:solidFill>
-          <a:srgbClr val="000000"/>
-        </a:solidFill>
-        <a:latin typeface="Arial"/>
-        <a:ea typeface="Arial"/>
-        <a:cs typeface="Arial"/>
-        <a:sym typeface="Arial"/>
-      </a:defRPr>
-    </a:lvl9pPr>
-  </p:notesStyle>
-</p:notesMaster>
-</file>
-
-<file path=ppt/notesSlides/notesSlide1.xml><?xml version="1.0" encoding="utf-8"?>
-<p:notes xmlns:a="http://schemas.openxmlformats.org/drawingml/2006/main" xmlns:r="http://schemas.openxmlformats.org/officeDocument/2006/relationships" xmlns:mc="http://schemas.openxmlformats.org/markup-compatibility/2006" xmlns:mv="urn:schemas-microsoft-com:mac:vml" xmlns:p="http://schemas.openxmlformats.org/presentationml/2006/main" xmlns:c="http://schemas.openxmlformats.org/drawingml/2006/chart" xmlns:dgm="http://schemas.openxmlformats.org/drawingml/2006/diagram" xmlns:o="urn:schemas-microsoft-com:office:office" xmlns:v="urn:schemas-microsoft-com:vml" xmlns:pvml="urn:schemas-microsoft-com:office:powerpoint" xmlns:com="http://schemas.openxmlformats.org/drawingml/2006/compatibility" xmlns:p14="http://schemas.microsoft.com/office/powerpoint/2010/main" xmlns:p15="http://schemas.microsoft.com/office/powerpoint/2012/main" xmlns:ahyp="http://schemas.microsoft.com/office/drawing/2018/hyperlinkcolor" showMasterPhAnim="0" showMasterSp="0">
-  <p:cSld>
-    <p:spTree>
-      <p:nvGrpSpPr>
-        <p:cNvPr id="8" name="Shape 8"/>
-        <p:cNvGrpSpPr/>
-        <p:nvPr/>
-      </p:nvGrpSpPr>
-      <p:grpSpPr>
-        <a:xfrm>
-          <a:off x="0" y="0"/>
-          <a:ext cx="0" cy="0"/>
-          <a:chOff x="0" y="0"/>
-          <a:chExt cx="0" cy="0"/>
-        </a:xfrm>
-      </p:grpSpPr>
-      <p:sp>
-        <p:nvSpPr>
-          <p:cNvPr id="9" name="Google Shape;9;p1:notes"/>
-          <p:cNvSpPr/>
-          <p:nvPr>
-            <p:ph idx="2" type="sldImg"/>
-          </p:nvPr>
-        </p:nvSpPr>
-        <p:spPr>
-          <a:xfrm>
-            <a:off x="0" y="0"/>
-            <a:ext cx="3000000" cy="3000000"/>
-          </a:xfrm>
-          <a:custGeom>
-            <a:rect b="b" l="l" r="r" t="t"/>
-            <a:pathLst>
-              <a:path extrusionOk="0" h="120000" w="120000">
-                <a:moveTo>
-                  <a:pt x="0" y="0"/>
-                </a:moveTo>
-                <a:lnTo>
-                  <a:pt x="120000" y="0"/>
-                </a:lnTo>
-                <a:lnTo>
-                  <a:pt x="120000" y="120000"/>
-                </a:lnTo>
-                <a:lnTo>
-                  <a:pt x="0" y="120000"/>
-                </a:lnTo>
-                <a:close/>
-              </a:path>
-            </a:pathLst>
-          </a:custGeom>
-          <a:noFill/>
-          <a:ln>
-            <a:noFill/>
-          </a:ln>
-        </p:spPr>
-      </p:sp>
-      <p:sp>
-        <p:nvSpPr>
-          <p:cNvPr id="10" name="Google Shape;10;p1:notes"/>
-          <p:cNvSpPr txBox="1"/>
-          <p:nvPr>
-            <p:ph idx="1" type="body"/>
-          </p:nvPr>
-        </p:nvSpPr>
-        <p:spPr>
-          <a:xfrm>
-            <a:off x="0" y="0"/>
-            <a:ext cx="3000000" cy="3000000"/>
-          </a:xfrm>
-          <a:prstGeom prst="rect">
-            <a:avLst/>
-          </a:prstGeom>
-          <a:noFill/>
-          <a:ln>
-            <a:noFill/>
-          </a:ln>
-        </p:spPr>
-        <p:txBody>
-          <a:bodyPr anchorCtr="0" anchor="t" bIns="45700" lIns="91425" spcFirstLastPara="1" rIns="91425" wrap="square" tIns="45700">
-            <a:noAutofit/>
-          </a:bodyPr>
-          <a:lstStyle/>
-          <a:p>
-            <a:pPr indent="0" lvl="0" marL="0" marR="0" rtl="0" algn="l">
-              <a:spcBef>
-                <a:spcPts val="0"/>
-              </a:spcBef>
-              <a:spcAft>
-                <a:spcPts val="0"/>
-              </a:spcAft>
-              <a:buNone/>
-            </a:pPr>
-            <a:r>
-              <a:t/>
-            </a:r>
-            <a:endParaRPr sz="1200">
-              <a:solidFill>
-                <a:schemeClr val="dk1"/>
-              </a:solidFill>
-              <a:latin typeface="Arial"/>
-              <a:ea typeface="Arial"/>
-              <a:cs typeface="Arial"/>
-              <a:sym typeface="Arial"/>
-            </a:endParaRPr>
-          </a:p>
-        </p:txBody>
-      </p:sp>
-      <p:sp>
-        <p:nvSpPr>
-          <p:cNvPr id="11" name="Google Shape;11;p1:notes"/>
-          <p:cNvSpPr txBox="1"/>
-          <p:nvPr>
-            <p:ph idx="12" type="sldNum"/>
-          </p:nvPr>
-        </p:nvSpPr>
-        <p:spPr>
-          <a:xfrm>
-            <a:off x="0" y="0"/>
-            <a:ext cx="3000000" cy="3000000"/>
-          </a:xfrm>
-          <a:prstGeom prst="rect">
-            <a:avLst/>
-          </a:prstGeom>
-          <a:noFill/>
-          <a:ln>
-            <a:noFill/>
-          </a:ln>
-        </p:spPr>
-        <p:txBody>
-          <a:bodyPr anchorCtr="0" anchor="t" bIns="45700" lIns="91425" spcFirstLastPara="1" rIns="91425" wrap="square" tIns="45700">
-            <a:noAutofit/>
-          </a:bodyPr>
-          <a:lstStyle/>
-          <a:p>
-            <a:pPr indent="0" lvl="0" marL="0" marR="0" rtl="0" algn="l">
-              <a:spcBef>
-                <a:spcPts val="0"/>
-              </a:spcBef>
-              <a:spcAft>
-                <a:spcPts val="0"/>
-              </a:spcAft>
-              <a:buNone/>
-            </a:pPr>
-            <a:fld id="{00000000-1234-1234-1234-123412341234}" type="slidenum">
-              <a:rPr lang="en-US" sz="1800">
-                <a:solidFill>
-                  <a:schemeClr val="dk1"/>
-                </a:solidFill>
-                <a:latin typeface="Arial"/>
-                <a:ea typeface="Arial"/>
-                <a:cs typeface="Arial"/>
-                <a:sym typeface="Arial"/>
-              </a:rPr>
-              <a:t>‹#›</a:t>
-            </a:fld>
-            <a:endParaRPr sz="1800">
-              <a:solidFill>
-                <a:schemeClr val="dk1"/>
-              </a:solidFill>
-              <a:latin typeface="Arial"/>
-              <a:ea typeface="Arial"/>
-              <a:cs typeface="Arial"/>
-              <a:sym typeface="Arial"/>
-            </a:endParaRPr>
-          </a:p>
-        </p:txBody>
-      </p:sp>
-    </p:spTree>
-  </p:cSld>
-  <p:clrMapOvr>
-    <a:masterClrMapping/>
-  </p:clrMapOvr>
-</p:notes>
-</file>
-
-<file path=ppt/notesSlides/notesSlide10.xml><?xml version="1.0" encoding="utf-8"?>
-<p:notes xmlns:a="http://schemas.openxmlformats.org/drawingml/2006/main" xmlns:r="http://schemas.openxmlformats.org/officeDocument/2006/relationships" xmlns:mc="http://schemas.openxmlformats.org/markup-compatibility/2006" xmlns:mv="urn:schemas-microsoft-com:mac:vml" xmlns:p="http://schemas.openxmlformats.org/presentationml/2006/main" xmlns:c="http://schemas.openxmlformats.org/drawingml/2006/chart" xmlns:dgm="http://schemas.openxmlformats.org/drawingml/2006/diagram" xmlns:o="urn:schemas-microsoft-com:office:office" xmlns:v="urn:schemas-microsoft-com:vml" xmlns:pvml="urn:schemas-microsoft-com:office:powerpoint" xmlns:com="http://schemas.openxmlformats.org/drawingml/2006/compatibility" xmlns:p14="http://schemas.microsoft.com/office/powerpoint/2010/main" xmlns:p15="http://schemas.microsoft.com/office/powerpoint/2012/main" xmlns:ahyp="http://schemas.microsoft.com/office/drawing/2018/hyperlinkcolor" showMasterPhAnim="0" showMasterSp="0">
-  <p:cSld>
-    <p:spTree>
-      <p:nvGrpSpPr>
-        <p:cNvPr id="230" name="Shape 230"/>
-        <p:cNvGrpSpPr/>
-        <p:nvPr/>
-      </p:nvGrpSpPr>
-      <p:grpSpPr>
-        <a:xfrm>
-          <a:off x="0" y="0"/>
-          <a:ext cx="0" cy="0"/>
-          <a:chOff x="0" y="0"/>
-          <a:chExt cx="0" cy="0"/>
-        </a:xfrm>
-      </p:grpSpPr>
-      <p:sp>
-        <p:nvSpPr>
-          <p:cNvPr id="231" name="Google Shape;231;p8:notes"/>
-          <p:cNvSpPr/>
-          <p:nvPr>
-            <p:ph idx="2" type="sldImg"/>
-          </p:nvPr>
-        </p:nvSpPr>
-        <p:spPr>
-          <a:xfrm>
-            <a:off x="0" y="0"/>
-            <a:ext cx="3000000" cy="3000000"/>
-          </a:xfrm>
-          <a:custGeom>
-            <a:rect b="b" l="l" r="r" t="t"/>
-            <a:pathLst>
-              <a:path extrusionOk="0" h="120000" w="120000">
-                <a:moveTo>
-                  <a:pt x="0" y="0"/>
-                </a:moveTo>
-                <a:lnTo>
-                  <a:pt x="120000" y="0"/>
-                </a:lnTo>
-                <a:lnTo>
-                  <a:pt x="120000" y="120000"/>
-                </a:lnTo>
-                <a:lnTo>
-                  <a:pt x="0" y="120000"/>
-                </a:lnTo>
-                <a:close/>
-              </a:path>
-            </a:pathLst>
-          </a:custGeom>
-          <a:noFill/>
-          <a:ln>
-            <a:noFill/>
-          </a:ln>
-        </p:spPr>
-      </p:sp>
-      <p:sp>
-        <p:nvSpPr>
-          <p:cNvPr id="232" name="Google Shape;232;p8:notes"/>
-          <p:cNvSpPr txBox="1"/>
-          <p:nvPr>
-            <p:ph idx="1" type="body"/>
-          </p:nvPr>
-        </p:nvSpPr>
-        <p:spPr>
-          <a:xfrm>
-            <a:off x="0" y="0"/>
-            <a:ext cx="3000000" cy="3000000"/>
-          </a:xfrm>
-          <a:prstGeom prst="rect">
-            <a:avLst/>
-          </a:prstGeom>
-          <a:noFill/>
-          <a:ln>
-            <a:noFill/>
-          </a:ln>
-        </p:spPr>
-        <p:txBody>
-          <a:bodyPr anchorCtr="0" anchor="t" bIns="45700" lIns="91425" spcFirstLastPara="1" rIns="91425" wrap="square" tIns="45700">
-            <a:noAutofit/>
-          </a:bodyPr>
-          <a:lstStyle/>
-          <a:p>
-            <a:pPr indent="0" lvl="0" marL="0" marR="0" rtl="0" algn="l">
-              <a:spcBef>
-                <a:spcPts val="0"/>
-              </a:spcBef>
-              <a:spcAft>
-                <a:spcPts val="0"/>
-              </a:spcAft>
-              <a:buNone/>
-            </a:pPr>
-            <a:r>
-              <a:t/>
-            </a:r>
-            <a:endParaRPr sz="1200">
-              <a:solidFill>
-                <a:schemeClr val="dk1"/>
-              </a:solidFill>
-              <a:latin typeface="Arial"/>
-              <a:ea typeface="Arial"/>
-              <a:cs typeface="Arial"/>
-              <a:sym typeface="Arial"/>
-            </a:endParaRPr>
-          </a:p>
-        </p:txBody>
-      </p:sp>
-      <p:sp>
-        <p:nvSpPr>
-          <p:cNvPr id="233" name="Google Shape;233;p8:notes"/>
-          <p:cNvSpPr txBox="1"/>
-          <p:nvPr>
-            <p:ph idx="12" type="sldNum"/>
-          </p:nvPr>
-        </p:nvSpPr>
-        <p:spPr>
-          <a:xfrm>
-            <a:off x="0" y="0"/>
-            <a:ext cx="3000000" cy="3000000"/>
-          </a:xfrm>
-          <a:prstGeom prst="rect">
-            <a:avLst/>
-          </a:prstGeom>
-          <a:noFill/>
-          <a:ln>
-            <a:noFill/>
-          </a:ln>
-        </p:spPr>
-        <p:txBody>
-          <a:bodyPr anchorCtr="0" anchor="t" bIns="45700" lIns="91425" spcFirstLastPara="1" rIns="91425" wrap="square" tIns="45700">
-            <a:noAutofit/>
-          </a:bodyPr>
-          <a:lstStyle/>
-          <a:p>
-            <a:pPr indent="0" lvl="0" marL="0" marR="0" rtl="0" algn="l">
-              <a:spcBef>
-                <a:spcPts val="0"/>
-              </a:spcBef>
-              <a:spcAft>
-                <a:spcPts val="0"/>
-              </a:spcAft>
-              <a:buNone/>
-            </a:pPr>
-            <a:fld id="{00000000-1234-1234-1234-123412341234}" type="slidenum">
-              <a:rPr lang="en-US" sz="1800">
-                <a:solidFill>
-                  <a:schemeClr val="dk1"/>
-                </a:solidFill>
-                <a:latin typeface="Arial"/>
-                <a:ea typeface="Arial"/>
-                <a:cs typeface="Arial"/>
-                <a:sym typeface="Arial"/>
-              </a:rPr>
-              <a:t>‹#›</a:t>
-            </a:fld>
-            <a:endParaRPr sz="1800">
-              <a:solidFill>
-                <a:schemeClr val="dk1"/>
-              </a:solidFill>
-              <a:latin typeface="Arial"/>
-              <a:ea typeface="Arial"/>
-              <a:cs typeface="Arial"/>
-              <a:sym typeface="Arial"/>
-            </a:endParaRPr>
-          </a:p>
-        </p:txBody>
-      </p:sp>
-    </p:spTree>
-  </p:cSld>
-  <p:clrMapOvr>
-    <a:masterClrMapping/>
-  </p:clrMapOvr>
-</p:notes>
-</file>
-
-<file path=ppt/notesSlides/notesSlide11.xml><?xml version="1.0" encoding="utf-8"?>
-<p:notes xmlns:a="http://schemas.openxmlformats.org/drawingml/2006/main" xmlns:r="http://schemas.openxmlformats.org/officeDocument/2006/relationships" xmlns:mc="http://schemas.openxmlformats.org/markup-compatibility/2006" xmlns:mv="urn:schemas-microsoft-com:mac:vml" xmlns:p="http://schemas.openxmlformats.org/presentationml/2006/main" xmlns:c="http://schemas.openxmlformats.org/drawingml/2006/chart" xmlns:dgm="http://schemas.openxmlformats.org/drawingml/2006/diagram" xmlns:o="urn:schemas-microsoft-com:office:office" xmlns:v="urn:schemas-microsoft-com:vml" xmlns:pvml="urn:schemas-microsoft-com:office:powerpoint" xmlns:com="http://schemas.openxmlformats.org/drawingml/2006/compatibility" xmlns:p14="http://schemas.microsoft.com/office/powerpoint/2010/main" xmlns:p15="http://schemas.microsoft.com/office/powerpoint/2012/main" xmlns:ahyp="http://schemas.microsoft.com/office/drawing/2018/hyperlinkcolor" showMasterPhAnim="0" showMasterSp="0">
-  <p:cSld>
-    <p:spTree>
-      <p:nvGrpSpPr>
-        <p:cNvPr id="256" name="Shape 256"/>
-        <p:cNvGrpSpPr/>
-        <p:nvPr/>
-      </p:nvGrpSpPr>
-      <p:grpSpPr>
-        <a:xfrm>
-          <a:off x="0" y="0"/>
-          <a:ext cx="0" cy="0"/>
-          <a:chOff x="0" y="0"/>
-          <a:chExt cx="0" cy="0"/>
-        </a:xfrm>
-      </p:grpSpPr>
-      <p:sp>
-        <p:nvSpPr>
-          <p:cNvPr id="257" name="Google Shape;257;p9:notes"/>
-          <p:cNvSpPr/>
-          <p:nvPr>
-            <p:ph idx="2" type="sldImg"/>
-          </p:nvPr>
-        </p:nvSpPr>
-        <p:spPr>
-          <a:xfrm>
-            <a:off x="0" y="0"/>
-            <a:ext cx="3000000" cy="3000000"/>
-          </a:xfrm>
-          <a:custGeom>
-            <a:rect b="b" l="l" r="r" t="t"/>
-            <a:pathLst>
-              <a:path extrusionOk="0" h="120000" w="120000">
-                <a:moveTo>
-                  <a:pt x="0" y="0"/>
-                </a:moveTo>
-                <a:lnTo>
-                  <a:pt x="120000" y="0"/>
-                </a:lnTo>
-                <a:lnTo>
-                  <a:pt x="120000" y="120000"/>
-                </a:lnTo>
-                <a:lnTo>
-                  <a:pt x="0" y="120000"/>
-                </a:lnTo>
-                <a:close/>
-              </a:path>
-            </a:pathLst>
-          </a:custGeom>
-          <a:noFill/>
-          <a:ln>
-            <a:noFill/>
-          </a:ln>
-        </p:spPr>
-      </p:sp>
-      <p:sp>
-        <p:nvSpPr>
-          <p:cNvPr id="258" name="Google Shape;258;p9:notes"/>
-          <p:cNvSpPr txBox="1"/>
-          <p:nvPr>
-            <p:ph idx="1" type="body"/>
-          </p:nvPr>
-        </p:nvSpPr>
-        <p:spPr>
-          <a:xfrm>
-            <a:off x="0" y="0"/>
-            <a:ext cx="3000000" cy="3000000"/>
-          </a:xfrm>
-          <a:prstGeom prst="rect">
-            <a:avLst/>
-          </a:prstGeom>
-          <a:noFill/>
-          <a:ln>
-            <a:noFill/>
-          </a:ln>
-        </p:spPr>
-        <p:txBody>
-          <a:bodyPr anchorCtr="0" anchor="t" bIns="45700" lIns="91425" spcFirstLastPara="1" rIns="91425" wrap="square" tIns="45700">
-            <a:noAutofit/>
-          </a:bodyPr>
-          <a:lstStyle/>
-          <a:p>
-            <a:pPr indent="0" lvl="0" marL="0" marR="0" rtl="0" algn="l">
-              <a:spcBef>
-                <a:spcPts val="0"/>
-              </a:spcBef>
-              <a:spcAft>
-                <a:spcPts val="0"/>
-              </a:spcAft>
-              <a:buNone/>
-            </a:pPr>
-            <a:r>
-              <a:t/>
-            </a:r>
-            <a:endParaRPr sz="1200">
-              <a:solidFill>
-                <a:schemeClr val="dk1"/>
-              </a:solidFill>
-              <a:latin typeface="Arial"/>
-              <a:ea typeface="Arial"/>
-              <a:cs typeface="Arial"/>
-              <a:sym typeface="Arial"/>
-            </a:endParaRPr>
-          </a:p>
-        </p:txBody>
-      </p:sp>
-      <p:sp>
-        <p:nvSpPr>
-          <p:cNvPr id="259" name="Google Shape;259;p9:notes"/>
-          <p:cNvSpPr txBox="1"/>
-          <p:nvPr>
-            <p:ph idx="12" type="sldNum"/>
-          </p:nvPr>
-        </p:nvSpPr>
-        <p:spPr>
-          <a:xfrm>
-            <a:off x="0" y="0"/>
-            <a:ext cx="3000000" cy="3000000"/>
-          </a:xfrm>
-          <a:prstGeom prst="rect">
-            <a:avLst/>
-          </a:prstGeom>
-          <a:noFill/>
-          <a:ln>
-            <a:noFill/>
-          </a:ln>
-        </p:spPr>
-        <p:txBody>
-          <a:bodyPr anchorCtr="0" anchor="t" bIns="45700" lIns="91425" spcFirstLastPara="1" rIns="91425" wrap="square" tIns="45700">
-            <a:noAutofit/>
-          </a:bodyPr>
-          <a:lstStyle/>
-          <a:p>
-            <a:pPr indent="0" lvl="0" marL="0" marR="0" rtl="0" algn="l">
-              <a:spcBef>
-                <a:spcPts val="0"/>
-              </a:spcBef>
-              <a:spcAft>
-                <a:spcPts val="0"/>
-              </a:spcAft>
-              <a:buNone/>
-            </a:pPr>
-            <a:fld id="{00000000-1234-1234-1234-123412341234}" type="slidenum">
-              <a:rPr lang="en-US" sz="1800">
-                <a:solidFill>
-                  <a:schemeClr val="dk1"/>
-                </a:solidFill>
-                <a:latin typeface="Arial"/>
-                <a:ea typeface="Arial"/>
-                <a:cs typeface="Arial"/>
-                <a:sym typeface="Arial"/>
-              </a:rPr>
-              <a:t>‹#›</a:t>
-            </a:fld>
-            <a:endParaRPr sz="1800">
-              <a:solidFill>
-                <a:schemeClr val="dk1"/>
-              </a:solidFill>
-              <a:latin typeface="Arial"/>
-              <a:ea typeface="Arial"/>
-              <a:cs typeface="Arial"/>
-              <a:sym typeface="Arial"/>
-            </a:endParaRPr>
-          </a:p>
-        </p:txBody>
-      </p:sp>
-    </p:spTree>
-  </p:cSld>
-  <p:clrMapOvr>
-    <a:masterClrMapping/>
-  </p:clrMapOvr>
-</p:notes>
-</file>
-
-<file path=ppt/notesSlides/notesSlide12.xml><?xml version="1.0" encoding="utf-8"?>
-<p:notes xmlns:a="http://schemas.openxmlformats.org/drawingml/2006/main" xmlns:r="http://schemas.openxmlformats.org/officeDocument/2006/relationships" xmlns:mc="http://schemas.openxmlformats.org/markup-compatibility/2006" xmlns:mv="urn:schemas-microsoft-com:mac:vml" xmlns:p="http://schemas.openxmlformats.org/presentationml/2006/main" xmlns:c="http://schemas.openxmlformats.org/drawingml/2006/chart" xmlns:dgm="http://schemas.openxmlformats.org/drawingml/2006/diagram" xmlns:o="urn:schemas-microsoft-com:office:office" xmlns:v="urn:schemas-microsoft-com:vml" xmlns:pvml="urn:schemas-microsoft-com:office:powerpoint" xmlns:com="http://schemas.openxmlformats.org/drawingml/2006/compatibility" xmlns:p14="http://schemas.microsoft.com/office/powerpoint/2010/main" xmlns:p15="http://schemas.microsoft.com/office/powerpoint/2012/main" xmlns:ahyp="http://schemas.microsoft.com/office/drawing/2018/hyperlinkcolor" showMasterPhAnim="0" showMasterSp="0">
-  <p:cSld>
-    <p:spTree>
-      <p:nvGrpSpPr>
-        <p:cNvPr id="278" name="Shape 278"/>
-        <p:cNvGrpSpPr/>
-        <p:nvPr/>
-      </p:nvGrpSpPr>
-      <p:grpSpPr>
-        <a:xfrm>
-          <a:off x="0" y="0"/>
-          <a:ext cx="0" cy="0"/>
-          <a:chOff x="0" y="0"/>
-          <a:chExt cx="0" cy="0"/>
-        </a:xfrm>
-      </p:grpSpPr>
-      <p:sp>
-        <p:nvSpPr>
-          <p:cNvPr id="279" name="Google Shape;279;g3d92ac71dd0_1_31:notes"/>
-          <p:cNvSpPr/>
-          <p:nvPr>
-            <p:ph idx="2" type="sldImg"/>
-          </p:nvPr>
-        </p:nvSpPr>
-        <p:spPr>
-          <a:xfrm>
-            <a:off x="0" y="0"/>
-            <a:ext cx="3000000" cy="3000000"/>
-          </a:xfrm>
-          <a:custGeom>
-            <a:rect b="b" l="l" r="r" t="t"/>
-            <a:pathLst>
-              <a:path extrusionOk="0" h="120000" w="120000">
-                <a:moveTo>
-                  <a:pt x="0" y="0"/>
-                </a:moveTo>
-                <a:lnTo>
-                  <a:pt x="120000" y="0"/>
-                </a:lnTo>
-                <a:lnTo>
-                  <a:pt x="120000" y="120000"/>
-                </a:lnTo>
-                <a:lnTo>
-                  <a:pt x="0" y="120000"/>
-                </a:lnTo>
-                <a:close/>
-              </a:path>
-            </a:pathLst>
-          </a:custGeom>
-          <a:noFill/>
-          <a:ln>
-            <a:noFill/>
-          </a:ln>
-        </p:spPr>
-      </p:sp>
-      <p:sp>
-        <p:nvSpPr>
-          <p:cNvPr id="280" name="Google Shape;280;g3d92ac71dd0_1_31:notes"/>
-          <p:cNvSpPr txBox="1"/>
-          <p:nvPr>
-            <p:ph idx="1" type="body"/>
-          </p:nvPr>
-        </p:nvSpPr>
-        <p:spPr>
-          <a:xfrm>
-            <a:off x="0" y="0"/>
-            <a:ext cx="3000000" cy="3000000"/>
-          </a:xfrm>
-          <a:prstGeom prst="rect">
-            <a:avLst/>
-          </a:prstGeom>
-          <a:noFill/>
-          <a:ln>
-            <a:noFill/>
-          </a:ln>
-        </p:spPr>
-        <p:txBody>
-          <a:bodyPr anchorCtr="0" anchor="t" bIns="45700" lIns="91425" spcFirstLastPara="1" rIns="91425" wrap="square" tIns="45700">
-            <a:noAutofit/>
-          </a:bodyPr>
-          <a:lstStyle/>
-          <a:p>
-            <a:pPr indent="0" lvl="0" marL="0" marR="0" rtl="0" algn="l">
-              <a:spcBef>
-                <a:spcPts val="0"/>
-              </a:spcBef>
-              <a:spcAft>
-                <a:spcPts val="0"/>
-              </a:spcAft>
-              <a:buNone/>
-            </a:pPr>
-            <a:r>
-              <a:t/>
-            </a:r>
-            <a:endParaRPr sz="1200">
-              <a:solidFill>
-                <a:schemeClr val="dk1"/>
-              </a:solidFill>
-              <a:latin typeface="Arial"/>
-              <a:ea typeface="Arial"/>
-              <a:cs typeface="Arial"/>
-              <a:sym typeface="Arial"/>
-            </a:endParaRPr>
-          </a:p>
-        </p:txBody>
-      </p:sp>
-      <p:sp>
-        <p:nvSpPr>
-          <p:cNvPr id="281" name="Google Shape;281;g3d92ac71dd0_1_31:notes"/>
-          <p:cNvSpPr txBox="1"/>
-          <p:nvPr>
-            <p:ph idx="12" type="sldNum"/>
-          </p:nvPr>
-        </p:nvSpPr>
-        <p:spPr>
-          <a:xfrm>
-            <a:off x="0" y="0"/>
-            <a:ext cx="3000000" cy="3000000"/>
-          </a:xfrm>
-          <a:prstGeom prst="rect">
-            <a:avLst/>
-          </a:prstGeom>
-          <a:noFill/>
-          <a:ln>
-            <a:noFill/>
-          </a:ln>
-        </p:spPr>
-        <p:txBody>
-          <a:bodyPr anchorCtr="0" anchor="t" bIns="45700" lIns="91425" spcFirstLastPara="1" rIns="91425" wrap="square" tIns="45700">
-            <a:noAutofit/>
-          </a:bodyPr>
-          <a:lstStyle/>
-          <a:p>
-            <a:pPr indent="0" lvl="0" marL="0" marR="0" rtl="0" algn="l">
-              <a:spcBef>
-                <a:spcPts val="0"/>
-              </a:spcBef>
-              <a:spcAft>
-                <a:spcPts val="0"/>
-              </a:spcAft>
-              <a:buNone/>
-            </a:pPr>
-            <a:fld id="{00000000-1234-1234-1234-123412341234}" type="slidenum">
-              <a:rPr lang="en-US" sz="1800">
-                <a:solidFill>
-                  <a:schemeClr val="dk1"/>
-                </a:solidFill>
-                <a:latin typeface="Arial"/>
-                <a:ea typeface="Arial"/>
-                <a:cs typeface="Arial"/>
-                <a:sym typeface="Arial"/>
-              </a:rPr>
-              <a:t>‹#›</a:t>
-            </a:fld>
-            <a:endParaRPr sz="1800">
-              <a:solidFill>
-                <a:schemeClr val="dk1"/>
-              </a:solidFill>
-              <a:latin typeface="Arial"/>
-              <a:ea typeface="Arial"/>
-              <a:cs typeface="Arial"/>
-              <a:sym typeface="Arial"/>
-            </a:endParaRPr>
-          </a:p>
-        </p:txBody>
-      </p:sp>
-    </p:spTree>
-  </p:cSld>
-  <p:clrMapOvr>
-    <a:masterClrMapping/>
-  </p:clrMapOvr>
-</p:notes>
-</file>
-
-<file path=ppt/notesSlides/notesSlide13.xml><?xml version="1.0" encoding="utf-8"?>
-<p:notes xmlns:a="http://schemas.openxmlformats.org/drawingml/2006/main" xmlns:r="http://schemas.openxmlformats.org/officeDocument/2006/relationships" xmlns:mc="http://schemas.openxmlformats.org/markup-compatibility/2006" xmlns:mv="urn:schemas-microsoft-com:mac:vml" xmlns:p="http://schemas.openxmlformats.org/presentationml/2006/main" xmlns:c="http://schemas.openxmlformats.org/drawingml/2006/chart" xmlns:dgm="http://schemas.openxmlformats.org/drawingml/2006/diagram" xmlns:o="urn:schemas-microsoft-com:office:office" xmlns:v="urn:schemas-microsoft-com:vml" xmlns:pvml="urn:schemas-microsoft-com:office:powerpoint" xmlns:com="http://schemas.openxmlformats.org/drawingml/2006/compatibility" xmlns:p14="http://schemas.microsoft.com/office/powerpoint/2010/main" xmlns:p15="http://schemas.microsoft.com/office/powerpoint/2012/main" xmlns:ahyp="http://schemas.microsoft.com/office/drawing/2018/hyperlinkcolor" showMasterPhAnim="0" showMasterSp="0">
-  <p:cSld>
-    <p:spTree>
-      <p:nvGrpSpPr>
-        <p:cNvPr id="303" name="Shape 303"/>
-        <p:cNvGrpSpPr/>
-        <p:nvPr/>
-      </p:nvGrpSpPr>
-      <p:grpSpPr>
-        <a:xfrm>
-          <a:off x="0" y="0"/>
-          <a:ext cx="0" cy="0"/>
-          <a:chOff x="0" y="0"/>
-          <a:chExt cx="0" cy="0"/>
-        </a:xfrm>
-      </p:grpSpPr>
-      <p:sp>
-        <p:nvSpPr>
-          <p:cNvPr id="304" name="Google Shape;304;g3e073069206_10_30:notes"/>
-          <p:cNvSpPr txBox="1"/>
-          <p:nvPr>
-            <p:ph idx="1" type="body"/>
-          </p:nvPr>
-        </p:nvSpPr>
-        <p:spPr>
-          <a:xfrm>
-            <a:off x="228600" y="4343400"/>
-            <a:ext cx="5486400" cy="4114800"/>
-          </a:xfrm>
-          <a:prstGeom prst="rect">
-            <a:avLst/>
-          </a:prstGeom>
-        </p:spPr>
-        <p:txBody>
-          <a:bodyPr anchorCtr="0" anchor="t" bIns="91425" lIns="91425" spcFirstLastPara="1" rIns="91425" wrap="square" tIns="91425">
-            <a:noAutofit/>
-          </a:bodyPr>
-          <a:lstStyle/>
-          <a:p>
-            <a:pPr indent="0" lvl="0" marL="0" rtl="0" algn="l">
-              <a:spcBef>
-                <a:spcPts val="0"/>
-              </a:spcBef>
-              <a:spcAft>
-                <a:spcPts val="0"/>
-              </a:spcAft>
-              <a:buNone/>
-            </a:pPr>
-            <a:r>
-              <a:t/>
-            </a:r>
-            <a:endParaRPr/>
-          </a:p>
-        </p:txBody>
-      </p:sp>
-    </p:spTree>
-  </p:cSld>
-  <p:clrMapOvr>
-    <a:masterClrMapping/>
-  </p:clrMapOvr>
-</p:notes>
-</file>
-
-<file path=ppt/notesSlides/notesSlide2.xml><?xml version="1.0" encoding="utf-8"?>
-<p:notes xmlns:a="http://schemas.openxmlformats.org/drawingml/2006/main" xmlns:r="http://schemas.openxmlformats.org/officeDocument/2006/relationships" xmlns:mc="http://schemas.openxmlformats.org/markup-compatibility/2006" xmlns:mv="urn:schemas-microsoft-com:mac:vml" xmlns:p="http://schemas.openxmlformats.org/presentationml/2006/main" xmlns:c="http://schemas.openxmlformats.org/drawingml/2006/chart" xmlns:dgm="http://schemas.openxmlformats.org/drawingml/2006/diagram" xmlns:o="urn:schemas-microsoft-com:office:office" xmlns:v="urn:schemas-microsoft-com:vml" xmlns:pvml="urn:schemas-microsoft-com:office:powerpoint" xmlns:com="http://schemas.openxmlformats.org/drawingml/2006/compatibility" xmlns:p14="http://schemas.microsoft.com/office/powerpoint/2010/main" xmlns:p15="http://schemas.microsoft.com/office/powerpoint/2012/main" xmlns:ahyp="http://schemas.microsoft.com/office/drawing/2018/hyperlinkcolor" showMasterPhAnim="0" showMasterSp="0">
-  <p:cSld>
-    <p:spTree>
-      <p:nvGrpSpPr>
-        <p:cNvPr id="33" name="Shape 33"/>
-        <p:cNvGrpSpPr/>
-        <p:nvPr/>
-      </p:nvGrpSpPr>
-      <p:grpSpPr>
-        <a:xfrm>
-          <a:off x="0" y="0"/>
-          <a:ext cx="0" cy="0"/>
-          <a:chOff x="0" y="0"/>
-          <a:chExt cx="0" cy="0"/>
-        </a:xfrm>
-      </p:grpSpPr>
-      <p:sp>
-        <p:nvSpPr>
-          <p:cNvPr id="34" name="Google Shape;34;p2:notes"/>
-          <p:cNvSpPr/>
-          <p:nvPr>
-            <p:ph idx="2" type="sldImg"/>
-          </p:nvPr>
-        </p:nvSpPr>
-        <p:spPr>
-          <a:xfrm>
-            <a:off x="0" y="0"/>
-            <a:ext cx="3000000" cy="3000000"/>
-          </a:xfrm>
-          <a:custGeom>
-            <a:rect b="b" l="l" r="r" t="t"/>
-            <a:pathLst>
-              <a:path extrusionOk="0" h="120000" w="120000">
-                <a:moveTo>
-                  <a:pt x="0" y="0"/>
-                </a:moveTo>
-                <a:lnTo>
-                  <a:pt x="120000" y="0"/>
-                </a:lnTo>
-                <a:lnTo>
-                  <a:pt x="120000" y="120000"/>
-                </a:lnTo>
-                <a:lnTo>
-                  <a:pt x="0" y="120000"/>
-                </a:lnTo>
-                <a:close/>
-              </a:path>
-            </a:pathLst>
-          </a:custGeom>
-          <a:noFill/>
-          <a:ln>
-            <a:noFill/>
-          </a:ln>
-        </p:spPr>
-      </p:sp>
-      <p:sp>
-        <p:nvSpPr>
-          <p:cNvPr id="35" name="Google Shape;35;p2:notes"/>
-          <p:cNvSpPr txBox="1"/>
-          <p:nvPr>
-            <p:ph idx="1" type="body"/>
-          </p:nvPr>
-        </p:nvSpPr>
-        <p:spPr>
-          <a:xfrm>
-            <a:off x="0" y="0"/>
-            <a:ext cx="3000000" cy="3000000"/>
-          </a:xfrm>
-          <a:prstGeom prst="rect">
-            <a:avLst/>
-          </a:prstGeom>
-          <a:noFill/>
-          <a:ln>
-            <a:noFill/>
-          </a:ln>
-        </p:spPr>
-        <p:txBody>
-          <a:bodyPr anchorCtr="0" anchor="t" bIns="45700" lIns="91425" spcFirstLastPara="1" rIns="91425" wrap="square" tIns="45700">
-            <a:noAutofit/>
-          </a:bodyPr>
-          <a:lstStyle/>
-          <a:p>
-            <a:pPr indent="0" lvl="0" marL="381000" marR="381000" rtl="0" algn="l">
-              <a:lnSpc>
-                <a:spcPct val="115000"/>
-              </a:lnSpc>
-              <a:spcBef>
-                <a:spcPts val="1200"/>
-              </a:spcBef>
-              <a:spcAft>
-                <a:spcPts val="0"/>
-              </a:spcAft>
-              <a:buClr>
-                <a:schemeClr val="dk1"/>
-              </a:buClr>
-              <a:buSzPts val="1100"/>
-              <a:buFont typeface="Arial"/>
-              <a:buNone/>
-            </a:pPr>
-            <a:r>
-              <a:rPr lang="en-US" sz="1200">
-                <a:solidFill>
-                  <a:schemeClr val="dk1"/>
-                </a:solidFill>
-              </a:rPr>
-              <a:t>"At its core, our design merges two completely different prediction philosophies. On the left, we have the Stride Value Predictor, or SVP. It's a mathematical backbone. It's highly accurate on predictable patterns like loop counters, but because it only looks at the PC, it is completely blind to context.</a:t>
-            </a:r>
-            <a:endParaRPr sz="1200">
-              <a:solidFill>
-                <a:schemeClr val="dk1"/>
-              </a:solidFill>
-            </a:endParaRPr>
-          </a:p>
-          <a:p>
-            <a:pPr indent="0" lvl="0" marL="381000" marR="381000" rtl="0" algn="l">
-              <a:lnSpc>
-                <a:spcPct val="115000"/>
-              </a:lnSpc>
-              <a:spcBef>
-                <a:spcPts val="1200"/>
-              </a:spcBef>
-              <a:spcAft>
-                <a:spcPts val="0"/>
-              </a:spcAft>
-              <a:buClr>
-                <a:schemeClr val="dk1"/>
-              </a:buClr>
-              <a:buSzPts val="1100"/>
-              <a:buFont typeface="Arial"/>
-              <a:buNone/>
-            </a:pPr>
-            <a:r>
-              <a:rPr lang="en-US" sz="1200">
-                <a:solidFill>
-                  <a:schemeClr val="dk1"/>
-                </a:solidFill>
-              </a:rPr>
-              <a:t>To solve that, we overlaid VTAGE. VTAGE is a tagged, multi-table predictor indexed by the global branch history. It provides the context the SVP lacks. By sweeping through geometrically increasing history lengths, VTAGE can learn complex, chaotic control-flow paths. The entire architectural challenge of this project was getting these two systems to complement each other within a strict 32-kilobyte budget."</a:t>
-            </a:r>
-            <a:endParaRPr sz="1200">
-              <a:solidFill>
-                <a:schemeClr val="dk1"/>
-              </a:solidFill>
-            </a:endParaRPr>
-          </a:p>
-          <a:p>
-            <a:pPr indent="0" lvl="0" marL="0" marR="0" rtl="0" algn="l">
-              <a:spcBef>
-                <a:spcPts val="1200"/>
-              </a:spcBef>
-              <a:spcAft>
-                <a:spcPts val="0"/>
-              </a:spcAft>
-              <a:buNone/>
-            </a:pPr>
-            <a:r>
-              <a:t/>
-            </a:r>
-            <a:endParaRPr sz="1200">
-              <a:solidFill>
-                <a:schemeClr val="dk1"/>
-              </a:solidFill>
-            </a:endParaRPr>
-          </a:p>
-        </p:txBody>
-      </p:sp>
-      <p:sp>
-        <p:nvSpPr>
-          <p:cNvPr id="36" name="Google Shape;36;p2:notes"/>
-          <p:cNvSpPr txBox="1"/>
-          <p:nvPr>
-            <p:ph idx="12" type="sldNum"/>
-          </p:nvPr>
-        </p:nvSpPr>
-        <p:spPr>
-          <a:xfrm>
-            <a:off x="0" y="0"/>
-            <a:ext cx="3000000" cy="3000000"/>
-          </a:xfrm>
-          <a:prstGeom prst="rect">
-            <a:avLst/>
-          </a:prstGeom>
-          <a:noFill/>
-          <a:ln>
-            <a:noFill/>
-          </a:ln>
-        </p:spPr>
-        <p:txBody>
-          <a:bodyPr anchorCtr="0" anchor="t" bIns="45700" lIns="91425" spcFirstLastPara="1" rIns="91425" wrap="square" tIns="45700">
-            <a:noAutofit/>
-          </a:bodyPr>
-          <a:lstStyle/>
-          <a:p>
-            <a:pPr indent="0" lvl="0" marL="0" marR="0" rtl="0" algn="l">
-              <a:spcBef>
-                <a:spcPts val="0"/>
-              </a:spcBef>
-              <a:spcAft>
-                <a:spcPts val="0"/>
-              </a:spcAft>
-              <a:buNone/>
-            </a:pPr>
-            <a:fld id="{00000000-1234-1234-1234-123412341234}" type="slidenum">
-              <a:rPr lang="en-US" sz="1800">
-                <a:solidFill>
-                  <a:schemeClr val="dk1"/>
-                </a:solidFill>
-                <a:latin typeface="Arial"/>
-                <a:ea typeface="Arial"/>
-                <a:cs typeface="Arial"/>
-                <a:sym typeface="Arial"/>
-              </a:rPr>
-              <a:t>‹#›</a:t>
-            </a:fld>
-            <a:endParaRPr sz="1800">
-              <a:solidFill>
-                <a:schemeClr val="dk1"/>
-              </a:solidFill>
-              <a:latin typeface="Arial"/>
-              <a:ea typeface="Arial"/>
-              <a:cs typeface="Arial"/>
-              <a:sym typeface="Arial"/>
-            </a:endParaRPr>
-          </a:p>
-        </p:txBody>
-      </p:sp>
-    </p:spTree>
-  </p:cSld>
-  <p:clrMapOvr>
-    <a:masterClrMapping/>
-  </p:clrMapOvr>
-</p:notes>
-</file>
-
-<file path=ppt/notesSlides/notesSlide3.xml><?xml version="1.0" encoding="utf-8"?>
-<p:notes xmlns:a="http://schemas.openxmlformats.org/drawingml/2006/main" xmlns:r="http://schemas.openxmlformats.org/officeDocument/2006/relationships" xmlns:mc="http://schemas.openxmlformats.org/markup-compatibility/2006" xmlns:mv="urn:schemas-microsoft-com:mac:vml" xmlns:p="http://schemas.openxmlformats.org/presentationml/2006/main" xmlns:c="http://schemas.openxmlformats.org/drawingml/2006/chart" xmlns:dgm="http://schemas.openxmlformats.org/drawingml/2006/diagram" xmlns:o="urn:schemas-microsoft-com:office:office" xmlns:v="urn:schemas-microsoft-com:vml" xmlns:pvml="urn:schemas-microsoft-com:office:powerpoint" xmlns:com="http://schemas.openxmlformats.org/drawingml/2006/compatibility" xmlns:p14="http://schemas.microsoft.com/office/powerpoint/2010/main" xmlns:p15="http://schemas.microsoft.com/office/powerpoint/2012/main" xmlns:ahyp="http://schemas.microsoft.com/office/drawing/2018/hyperlinkcolor" showMasterPhAnim="0" showMasterSp="0">
-  <p:cSld>
-    <p:spTree>
-      <p:nvGrpSpPr>
-        <p:cNvPr id="61" name="Shape 61"/>
-        <p:cNvGrpSpPr/>
-        <p:nvPr/>
-      </p:nvGrpSpPr>
-      <p:grpSpPr>
-        <a:xfrm>
-          <a:off x="0" y="0"/>
-          <a:ext cx="0" cy="0"/>
-          <a:chOff x="0" y="0"/>
-          <a:chExt cx="0" cy="0"/>
-        </a:xfrm>
-      </p:grpSpPr>
-      <p:sp>
-        <p:nvSpPr>
-          <p:cNvPr id="62" name="Google Shape;62;g3e6275e1d8a_16_7:notes"/>
-          <p:cNvSpPr/>
-          <p:nvPr>
-            <p:ph idx="2" type="sldImg"/>
-          </p:nvPr>
-        </p:nvSpPr>
-        <p:spPr>
-          <a:xfrm>
-            <a:off x="0" y="0"/>
-            <a:ext cx="3000000" cy="3000000"/>
-          </a:xfrm>
-          <a:custGeom>
-            <a:rect b="b" l="l" r="r" t="t"/>
-            <a:pathLst>
-              <a:path extrusionOk="0" h="120000" w="120000">
-                <a:moveTo>
-                  <a:pt x="0" y="0"/>
-                </a:moveTo>
-                <a:lnTo>
-                  <a:pt x="120000" y="0"/>
-                </a:lnTo>
-                <a:lnTo>
-                  <a:pt x="120000" y="120000"/>
-                </a:lnTo>
-                <a:lnTo>
-                  <a:pt x="0" y="120000"/>
-                </a:lnTo>
-                <a:close/>
-              </a:path>
-            </a:pathLst>
-          </a:custGeom>
-          <a:noFill/>
-          <a:ln>
-            <a:noFill/>
-          </a:ln>
-        </p:spPr>
-      </p:sp>
-      <p:sp>
-        <p:nvSpPr>
-          <p:cNvPr id="63" name="Google Shape;63;g3e6275e1d8a_16_7:notes"/>
-          <p:cNvSpPr txBox="1"/>
-          <p:nvPr>
-            <p:ph idx="1" type="body"/>
-          </p:nvPr>
-        </p:nvSpPr>
-        <p:spPr>
-          <a:xfrm>
-            <a:off x="0" y="0"/>
-            <a:ext cx="3000000" cy="3000000"/>
-          </a:xfrm>
-          <a:prstGeom prst="rect">
-            <a:avLst/>
-          </a:prstGeom>
-          <a:noFill/>
-          <a:ln>
-            <a:noFill/>
-          </a:ln>
-        </p:spPr>
-        <p:txBody>
-          <a:bodyPr anchorCtr="0" anchor="t" bIns="45700" lIns="91425" spcFirstLastPara="1" rIns="91425" wrap="square" tIns="45700">
-            <a:noAutofit/>
-          </a:bodyPr>
-          <a:lstStyle/>
-          <a:p>
-            <a:pPr indent="0" lvl="0" marL="0" rtl="0" algn="l">
-              <a:spcBef>
-                <a:spcPts val="0"/>
-              </a:spcBef>
-              <a:spcAft>
-                <a:spcPts val="0"/>
-              </a:spcAft>
-              <a:buClr>
-                <a:schemeClr val="dk1"/>
-              </a:buClr>
-              <a:buSzPts val="1100"/>
-              <a:buFont typeface="Arial"/>
-              <a:buNone/>
-            </a:pPr>
-            <a:r>
-              <a:rPr lang="en-US" sz="1050">
-                <a:solidFill>
-                  <a:srgbClr val="1F1F1F"/>
-                </a:solidFill>
-                <a:highlight>
-                  <a:srgbClr val="FFFFFF"/>
-                </a:highlight>
-                <a:latin typeface="Roboto"/>
-                <a:ea typeface="Roboto"/>
-                <a:cs typeface="Roboto"/>
-                <a:sym typeface="Roboto"/>
-              </a:rPr>
-              <a:t>"This slide illustrates the high-level block diagram and the critical flow of data through our hybrid value predictor.</a:t>
-            </a:r>
-            <a:endParaRPr sz="1050">
-              <a:solidFill>
-                <a:srgbClr val="1F1F1F"/>
-              </a:solidFill>
-              <a:highlight>
-                <a:srgbClr val="FFFFFF"/>
-              </a:highlight>
-              <a:latin typeface="Roboto"/>
-              <a:ea typeface="Roboto"/>
-              <a:cs typeface="Roboto"/>
-              <a:sym typeface="Roboto"/>
-            </a:endParaRPr>
-          </a:p>
-          <a:p>
-            <a:pPr indent="0" lvl="0" marL="0" rtl="0" algn="l">
-              <a:spcBef>
-                <a:spcPts val="0"/>
-              </a:spcBef>
-              <a:spcAft>
-                <a:spcPts val="0"/>
-              </a:spcAft>
-              <a:buClr>
-                <a:schemeClr val="dk1"/>
-              </a:buClr>
-              <a:buSzPts val="1100"/>
-              <a:buFont typeface="Arial"/>
-              <a:buNone/>
-            </a:pPr>
-            <a:r>
-              <a:t/>
-            </a:r>
-            <a:endParaRPr sz="1050">
-              <a:solidFill>
-                <a:srgbClr val="1F1F1F"/>
-              </a:solidFill>
-              <a:highlight>
-                <a:srgbClr val="FFFFFF"/>
-              </a:highlight>
-              <a:latin typeface="Roboto"/>
-              <a:ea typeface="Roboto"/>
-              <a:cs typeface="Roboto"/>
-              <a:sym typeface="Roboto"/>
-            </a:endParaRPr>
-          </a:p>
-          <a:p>
-            <a:pPr indent="0" lvl="0" marL="0" rtl="0" algn="l">
-              <a:spcBef>
-                <a:spcPts val="0"/>
-              </a:spcBef>
-              <a:spcAft>
-                <a:spcPts val="0"/>
-              </a:spcAft>
-              <a:buClr>
-                <a:schemeClr val="dk1"/>
-              </a:buClr>
-              <a:buSzPts val="1100"/>
-              <a:buFont typeface="Arial"/>
-              <a:buNone/>
-            </a:pPr>
-            <a:r>
-              <a:rPr lang="en-US" sz="1050">
-                <a:solidFill>
-                  <a:srgbClr val="1F1F1F"/>
-                </a:solidFill>
-                <a:highlight>
-                  <a:srgbClr val="FFFFFF"/>
-                </a:highlight>
-                <a:latin typeface="Roboto"/>
-                <a:ea typeface="Roboto"/>
-                <a:cs typeface="Roboto"/>
-                <a:sym typeface="Roboto"/>
-              </a:rPr>
-              <a:t>The process begins with a </a:t>
-            </a:r>
-            <a:r>
-              <a:rPr b="1" lang="en-US" sz="1050">
-                <a:solidFill>
-                  <a:srgbClr val="1F1F1F"/>
-                </a:solidFill>
-                <a:highlight>
-                  <a:srgbClr val="FFFFFF"/>
-                </a:highlight>
-                <a:latin typeface="Roboto"/>
-                <a:ea typeface="Roboto"/>
-                <a:cs typeface="Roboto"/>
-                <a:sym typeface="Roboto"/>
-              </a:rPr>
-              <a:t>Concurrent Lookup</a:t>
-            </a:r>
-            <a:r>
-              <a:rPr lang="en-US" sz="1050">
-                <a:solidFill>
-                  <a:srgbClr val="1F1F1F"/>
-                </a:solidFill>
-                <a:highlight>
-                  <a:srgbClr val="FFFFFF"/>
-                </a:highlight>
-                <a:latin typeface="Roboto"/>
-                <a:ea typeface="Roboto"/>
-                <a:cs typeface="Roboto"/>
-                <a:sym typeface="Roboto"/>
-              </a:rPr>
-              <a:t>: every instruction simultaneously queries the Stride Value Predictor, or SVP, and the multiple VTAGE tables.</a:t>
-            </a:r>
-            <a:r>
-              <a:rPr lang="en-US" sz="700">
-                <a:solidFill>
-                  <a:srgbClr val="1F1F1F"/>
-                </a:solidFill>
-                <a:highlight>
-                  <a:srgbClr val="F0F4F9"/>
-                </a:highlight>
-                <a:uFill>
-                  <a:noFill/>
-                </a:uFill>
-                <a:latin typeface="Roboto"/>
-                <a:ea typeface="Roboto"/>
-                <a:cs typeface="Roboto"/>
-                <a:sym typeface="Roboto"/>
-                <a:hlinkClick r:id="rId2">
-                  <a:extLst>
-                    <a:ext uri="{A12FA001-AC4F-418D-AE19-62706E023703}">
-                      <ahyp:hlinkClr val="tx"/>
-                    </a:ext>
-                  </a:extLst>
-                </a:hlinkClick>
-              </a:rPr>
-              <a:t>1</a:t>
-            </a:r>
-            <a:endParaRPr sz="700">
-              <a:solidFill>
-                <a:srgbClr val="1F1F1F"/>
-              </a:solidFill>
-              <a:highlight>
-                <a:srgbClr val="F0F4F9"/>
-              </a:highlight>
-              <a:latin typeface="Roboto"/>
-              <a:ea typeface="Roboto"/>
-              <a:cs typeface="Roboto"/>
-              <a:sym typeface="Roboto"/>
-            </a:endParaRPr>
-          </a:p>
-          <a:p>
-            <a:pPr indent="0" lvl="0" marL="0" rtl="0" algn="l">
-              <a:spcBef>
-                <a:spcPts val="0"/>
-              </a:spcBef>
-              <a:spcAft>
-                <a:spcPts val="0"/>
-              </a:spcAft>
-              <a:buClr>
-                <a:schemeClr val="dk1"/>
-              </a:buClr>
-              <a:buSzPts val="1100"/>
-              <a:buFont typeface="Arial"/>
-              <a:buNone/>
-            </a:pPr>
-            <a:r>
-              <a:t/>
-            </a:r>
-            <a:endParaRPr sz="1050">
-              <a:solidFill>
-                <a:srgbClr val="1F1F1F"/>
-              </a:solidFill>
-              <a:highlight>
-                <a:srgbClr val="FFFFFF"/>
-              </a:highlight>
-              <a:latin typeface="Roboto"/>
-              <a:ea typeface="Roboto"/>
-              <a:cs typeface="Roboto"/>
-              <a:sym typeface="Roboto"/>
-            </a:endParaRPr>
-          </a:p>
-          <a:p>
-            <a:pPr indent="0" lvl="0" marL="0" rtl="0" algn="l">
-              <a:spcBef>
-                <a:spcPts val="0"/>
-              </a:spcBef>
-              <a:spcAft>
-                <a:spcPts val="0"/>
-              </a:spcAft>
-              <a:buClr>
-                <a:schemeClr val="dk1"/>
-              </a:buClr>
-              <a:buSzPts val="1100"/>
-              <a:buFont typeface="Arial"/>
-              <a:buNone/>
-            </a:pPr>
-            <a:r>
-              <a:rPr lang="en-US" sz="1050">
-                <a:solidFill>
-                  <a:srgbClr val="1F1F1F"/>
-                </a:solidFill>
-                <a:highlight>
-                  <a:srgbClr val="FFFFFF"/>
-                </a:highlight>
-                <a:latin typeface="Roboto"/>
-                <a:ea typeface="Roboto"/>
-                <a:cs typeface="Roboto"/>
-                <a:sym typeface="Roboto"/>
-              </a:rPr>
-              <a:t>We then enter the </a:t>
-            </a:r>
-            <a:r>
-              <a:rPr b="1" lang="en-US" sz="1050">
-                <a:solidFill>
-                  <a:srgbClr val="1F1F1F"/>
-                </a:solidFill>
-                <a:highlight>
-                  <a:srgbClr val="FFFFFF"/>
-                </a:highlight>
-                <a:latin typeface="Roboto"/>
-                <a:ea typeface="Roboto"/>
-                <a:cs typeface="Roboto"/>
-                <a:sym typeface="Roboto"/>
-              </a:rPr>
-              <a:t>Provider Selection</a:t>
-            </a:r>
-            <a:r>
-              <a:rPr lang="en-US" sz="1050">
-                <a:solidFill>
-                  <a:srgbClr val="1F1F1F"/>
-                </a:solidFill>
-                <a:highlight>
-                  <a:srgbClr val="FFFFFF"/>
-                </a:highlight>
-                <a:latin typeface="Roboto"/>
-                <a:ea typeface="Roboto"/>
-                <a:cs typeface="Roboto"/>
-                <a:sym typeface="Roboto"/>
-              </a:rPr>
-              <a:t> phase: the longest-matching VTAGE table is selected as the primary 'Provider,' and the second longest becomes the 'Alternate,' which is used later for training decisions.</a:t>
-            </a:r>
-            <a:r>
-              <a:rPr lang="en-US" sz="700">
-                <a:solidFill>
-                  <a:srgbClr val="1F1F1F"/>
-                </a:solidFill>
-                <a:highlight>
-                  <a:srgbClr val="F0F4F9"/>
-                </a:highlight>
-                <a:uFill>
-                  <a:noFill/>
-                </a:uFill>
-                <a:latin typeface="Roboto"/>
-                <a:ea typeface="Roboto"/>
-                <a:cs typeface="Roboto"/>
-                <a:sym typeface="Roboto"/>
-                <a:hlinkClick r:id="rId3">
-                  <a:extLst>
-                    <a:ext uri="{A12FA001-AC4F-418D-AE19-62706E023703}">
-                      <ahyp:hlinkClr val="tx"/>
-                    </a:ext>
-                  </a:extLst>
-                </a:hlinkClick>
-              </a:rPr>
-              <a:t>1</a:t>
-            </a:r>
-            <a:endParaRPr sz="700">
-              <a:solidFill>
-                <a:srgbClr val="1F1F1F"/>
-              </a:solidFill>
-              <a:highlight>
-                <a:srgbClr val="F0F4F9"/>
-              </a:highlight>
-              <a:latin typeface="Roboto"/>
-              <a:ea typeface="Roboto"/>
-              <a:cs typeface="Roboto"/>
-              <a:sym typeface="Roboto"/>
-            </a:endParaRPr>
-          </a:p>
-          <a:p>
-            <a:pPr indent="0" lvl="0" marL="0" rtl="0" algn="l">
-              <a:spcBef>
-                <a:spcPts val="0"/>
-              </a:spcBef>
-              <a:spcAft>
-                <a:spcPts val="0"/>
-              </a:spcAft>
-              <a:buClr>
-                <a:schemeClr val="dk1"/>
-              </a:buClr>
-              <a:buSzPts val="1100"/>
-              <a:buFont typeface="Arial"/>
-              <a:buNone/>
-            </a:pPr>
-            <a:r>
-              <a:t/>
-            </a:r>
-            <a:endParaRPr sz="1050">
-              <a:solidFill>
-                <a:srgbClr val="1F1F1F"/>
-              </a:solidFill>
-              <a:highlight>
-                <a:srgbClr val="FFFFFF"/>
-              </a:highlight>
-              <a:latin typeface="Roboto"/>
-              <a:ea typeface="Roboto"/>
-              <a:cs typeface="Roboto"/>
-              <a:sym typeface="Roboto"/>
-            </a:endParaRPr>
-          </a:p>
-          <a:p>
-            <a:pPr indent="0" lvl="0" marL="0" rtl="0" algn="l">
-              <a:spcBef>
-                <a:spcPts val="0"/>
-              </a:spcBef>
-              <a:spcAft>
-                <a:spcPts val="0"/>
-              </a:spcAft>
-              <a:buClr>
-                <a:schemeClr val="dk1"/>
-              </a:buClr>
-              <a:buSzPts val="1100"/>
-              <a:buFont typeface="Arial"/>
-              <a:buNone/>
-            </a:pPr>
-            <a:r>
-              <a:rPr lang="en-US" sz="1050">
-                <a:solidFill>
-                  <a:srgbClr val="1F1F1F"/>
-                </a:solidFill>
-                <a:highlight>
-                  <a:srgbClr val="FFFFFF"/>
-                </a:highlight>
-                <a:latin typeface="Roboto"/>
-                <a:ea typeface="Roboto"/>
-                <a:cs typeface="Roboto"/>
-                <a:sym typeface="Roboto"/>
-              </a:rPr>
-              <a:t>Our </a:t>
-            </a:r>
-            <a:r>
-              <a:rPr b="1" lang="en-US" sz="1050">
-                <a:solidFill>
-                  <a:srgbClr val="1F1F1F"/>
-                </a:solidFill>
-                <a:highlight>
-                  <a:srgbClr val="FFFFFF"/>
-                </a:highlight>
-                <a:latin typeface="Roboto"/>
-                <a:ea typeface="Roboto"/>
-                <a:cs typeface="Roboto"/>
-                <a:sym typeface="Roboto"/>
-              </a:rPr>
-              <a:t>Fallback Hierarchy</a:t>
-            </a:r>
-            <a:r>
-              <a:rPr lang="en-US" sz="1050">
-                <a:solidFill>
-                  <a:srgbClr val="1F1F1F"/>
-                </a:solidFill>
-                <a:highlight>
-                  <a:srgbClr val="FFFFFF"/>
-                </a:highlight>
-                <a:latin typeface="Roboto"/>
-                <a:ea typeface="Roboto"/>
-                <a:cs typeface="Roboto"/>
-                <a:sym typeface="Roboto"/>
-              </a:rPr>
-              <a:t> means that if VTAGE provides no match, SVP acts as the backup prediction. If SVP also misses, no prediction is attempted for that slot.</a:t>
-            </a:r>
-            <a:r>
-              <a:rPr lang="en-US" sz="700">
-                <a:solidFill>
-                  <a:srgbClr val="1F1F1F"/>
-                </a:solidFill>
-                <a:highlight>
-                  <a:srgbClr val="F0F4F9"/>
-                </a:highlight>
-                <a:uFill>
-                  <a:noFill/>
-                </a:uFill>
-                <a:latin typeface="Roboto"/>
-                <a:ea typeface="Roboto"/>
-                <a:cs typeface="Roboto"/>
-                <a:sym typeface="Roboto"/>
-                <a:hlinkClick r:id="rId4">
-                  <a:extLst>
-                    <a:ext uri="{A12FA001-AC4F-418D-AE19-62706E023703}">
-                      <ahyp:hlinkClr val="tx"/>
-                    </a:ext>
-                  </a:extLst>
-                </a:hlinkClick>
-              </a:rPr>
-              <a:t>1</a:t>
-            </a:r>
-            <a:endParaRPr sz="700">
-              <a:solidFill>
-                <a:srgbClr val="1F1F1F"/>
-              </a:solidFill>
-              <a:highlight>
-                <a:srgbClr val="F0F4F9"/>
-              </a:highlight>
-              <a:latin typeface="Roboto"/>
-              <a:ea typeface="Roboto"/>
-              <a:cs typeface="Roboto"/>
-              <a:sym typeface="Roboto"/>
-            </a:endParaRPr>
-          </a:p>
-          <a:p>
-            <a:pPr indent="0" lvl="0" marL="0" rtl="0" algn="l">
-              <a:spcBef>
-                <a:spcPts val="0"/>
-              </a:spcBef>
-              <a:spcAft>
-                <a:spcPts val="0"/>
-              </a:spcAft>
-              <a:buClr>
-                <a:schemeClr val="dk1"/>
-              </a:buClr>
-              <a:buSzPts val="1100"/>
-              <a:buFont typeface="Arial"/>
-              <a:buNone/>
-            </a:pPr>
-            <a:r>
-              <a:t/>
-            </a:r>
-            <a:endParaRPr sz="1050">
-              <a:solidFill>
-                <a:srgbClr val="1F1F1F"/>
-              </a:solidFill>
-              <a:highlight>
-                <a:srgbClr val="FFFFFF"/>
-              </a:highlight>
-              <a:latin typeface="Roboto"/>
-              <a:ea typeface="Roboto"/>
-              <a:cs typeface="Roboto"/>
-              <a:sym typeface="Roboto"/>
-            </a:endParaRPr>
-          </a:p>
-          <a:p>
-            <a:pPr indent="0" lvl="0" marL="0" marR="0" rtl="0" algn="l">
-              <a:spcBef>
-                <a:spcPts val="0"/>
-              </a:spcBef>
-              <a:spcAft>
-                <a:spcPts val="0"/>
-              </a:spcAft>
-              <a:buNone/>
-            </a:pPr>
-            <a:r>
-              <a:rPr lang="en-US" sz="1050">
-                <a:solidFill>
-                  <a:srgbClr val="1F1F1F"/>
-                </a:solidFill>
-                <a:highlight>
-                  <a:srgbClr val="FFFFFF"/>
-                </a:highlight>
-                <a:latin typeface="Roboto"/>
-                <a:ea typeface="Roboto"/>
-                <a:cs typeface="Roboto"/>
-                <a:sym typeface="Roboto"/>
-              </a:rPr>
-              <a:t>Finally, the prediction is placed into the </a:t>
-            </a:r>
-            <a:r>
-              <a:rPr b="1" lang="en-US" sz="1050">
-                <a:solidFill>
-                  <a:srgbClr val="1F1F1F"/>
-                </a:solidFill>
-                <a:highlight>
-                  <a:srgbClr val="FFFFFF"/>
-                </a:highlight>
-                <a:latin typeface="Roboto"/>
-                <a:ea typeface="Roboto"/>
-                <a:cs typeface="Roboto"/>
-                <a:sym typeface="Roboto"/>
-              </a:rPr>
-              <a:t>Value Prediction Queue (VPQ)</a:t>
-            </a:r>
-            <a:r>
-              <a:rPr lang="en-US" sz="1050">
-                <a:solidFill>
-                  <a:srgbClr val="1F1F1F"/>
-                </a:solidFill>
-                <a:highlight>
-                  <a:srgbClr val="FFFFFF"/>
-                </a:highlight>
-                <a:latin typeface="Roboto"/>
-                <a:ea typeface="Roboto"/>
-                <a:cs typeface="Roboto"/>
-                <a:sym typeface="Roboto"/>
-              </a:rPr>
-              <a:t>. Here, we capture a snapshot of the global branch history, the Program Counter tag, and all prediction metadata from both the provider and the alternate. This concurrent approach ensures that we get the best prediction—whether from the deterministic SVP or the contextual VTAGE—for every single</a:t>
-            </a:r>
-            <a:endParaRPr sz="1200">
-              <a:solidFill>
-                <a:schemeClr val="dk1"/>
-              </a:solidFill>
-            </a:endParaRPr>
-          </a:p>
-        </p:txBody>
-      </p:sp>
-      <p:sp>
-        <p:nvSpPr>
-          <p:cNvPr id="64" name="Google Shape;64;g3e6275e1d8a_16_7:notes"/>
-          <p:cNvSpPr txBox="1"/>
-          <p:nvPr>
-            <p:ph idx="12" type="sldNum"/>
-          </p:nvPr>
-        </p:nvSpPr>
-        <p:spPr>
-          <a:xfrm>
-            <a:off x="0" y="0"/>
-            <a:ext cx="3000000" cy="3000000"/>
-          </a:xfrm>
-          <a:prstGeom prst="rect">
-            <a:avLst/>
-          </a:prstGeom>
-          <a:noFill/>
-          <a:ln>
-            <a:noFill/>
-          </a:ln>
-        </p:spPr>
-        <p:txBody>
-          <a:bodyPr anchorCtr="0" anchor="t" bIns="45700" lIns="91425" spcFirstLastPara="1" rIns="91425" wrap="square" tIns="45700">
-            <a:noAutofit/>
-          </a:bodyPr>
-          <a:lstStyle/>
-          <a:p>
-            <a:pPr indent="0" lvl="0" marL="0" marR="0" rtl="0" algn="l">
-              <a:spcBef>
-                <a:spcPts val="0"/>
-              </a:spcBef>
-              <a:spcAft>
-                <a:spcPts val="0"/>
-              </a:spcAft>
-              <a:buNone/>
-            </a:pPr>
-            <a:fld id="{00000000-1234-1234-1234-123412341234}" type="slidenum">
-              <a:rPr lang="en-US" sz="1800">
-                <a:solidFill>
-                  <a:schemeClr val="dk1"/>
-                </a:solidFill>
-                <a:latin typeface="Arial"/>
-                <a:ea typeface="Arial"/>
-                <a:cs typeface="Arial"/>
-                <a:sym typeface="Arial"/>
-              </a:rPr>
-              <a:t>‹#›</a:t>
-            </a:fld>
-            <a:endParaRPr sz="1800">
-              <a:solidFill>
-                <a:schemeClr val="dk1"/>
-              </a:solidFill>
-              <a:latin typeface="Arial"/>
-              <a:ea typeface="Arial"/>
-              <a:cs typeface="Arial"/>
-              <a:sym typeface="Arial"/>
-            </a:endParaRPr>
-          </a:p>
-        </p:txBody>
-      </p:sp>
-    </p:spTree>
-  </p:cSld>
-  <p:clrMapOvr>
-    <a:masterClrMapping/>
-  </p:clrMapOvr>
-</p:notes>
-</file>
-
-<file path=ppt/notesSlides/notesSlide4.xml><?xml version="1.0" encoding="utf-8"?>
-<p:notes xmlns:a="http://schemas.openxmlformats.org/drawingml/2006/main" xmlns:r="http://schemas.openxmlformats.org/officeDocument/2006/relationships" xmlns:mc="http://schemas.openxmlformats.org/markup-compatibility/2006" xmlns:mv="urn:schemas-microsoft-com:mac:vml" xmlns:p="http://schemas.openxmlformats.org/presentationml/2006/main" xmlns:c="http://schemas.openxmlformats.org/drawingml/2006/chart" xmlns:dgm="http://schemas.openxmlformats.org/drawingml/2006/diagram" xmlns:o="urn:schemas-microsoft-com:office:office" xmlns:v="urn:schemas-microsoft-com:vml" xmlns:pvml="urn:schemas-microsoft-com:office:powerpoint" xmlns:com="http://schemas.openxmlformats.org/drawingml/2006/compatibility" xmlns:p14="http://schemas.microsoft.com/office/powerpoint/2010/main" xmlns:p15="http://schemas.microsoft.com/office/powerpoint/2012/main" xmlns:ahyp="http://schemas.microsoft.com/office/drawing/2018/hyperlinkcolor" showMasterPhAnim="0" showMasterSp="0">
-  <p:cSld>
-    <p:spTree>
-      <p:nvGrpSpPr>
-        <p:cNvPr id="70" name="Shape 70"/>
-        <p:cNvGrpSpPr/>
-        <p:nvPr/>
-      </p:nvGrpSpPr>
-      <p:grpSpPr>
-        <a:xfrm>
-          <a:off x="0" y="0"/>
-          <a:ext cx="0" cy="0"/>
-          <a:chOff x="0" y="0"/>
-          <a:chExt cx="0" cy="0"/>
-        </a:xfrm>
-      </p:grpSpPr>
-      <p:sp>
-        <p:nvSpPr>
-          <p:cNvPr id="71" name="Google Shape;71;g3e073069206_0_98:notes"/>
-          <p:cNvSpPr txBox="1"/>
-          <p:nvPr>
-            <p:ph idx="1" type="body"/>
-          </p:nvPr>
-        </p:nvSpPr>
-        <p:spPr>
-          <a:xfrm>
-            <a:off x="228600" y="4343400"/>
-            <a:ext cx="5486400" cy="4114800"/>
-          </a:xfrm>
-          <a:prstGeom prst="rect">
-            <a:avLst/>
-          </a:prstGeom>
-        </p:spPr>
-        <p:txBody>
-          <a:bodyPr anchorCtr="0" anchor="t" bIns="91425" lIns="91425" spcFirstLastPara="1" rIns="91425" wrap="square" tIns="91425">
-            <a:noAutofit/>
-          </a:bodyPr>
-          <a:lstStyle/>
-          <a:p>
-            <a:pPr indent="0" lvl="0" marL="0" rtl="0" algn="l">
-              <a:lnSpc>
-                <a:spcPct val="115000"/>
-              </a:lnSpc>
-              <a:spcBef>
-                <a:spcPts val="1200"/>
-              </a:spcBef>
-              <a:spcAft>
-                <a:spcPts val="0"/>
-              </a:spcAft>
-              <a:buClr>
-                <a:schemeClr val="dk1"/>
-              </a:buClr>
-              <a:buSzPts val="1100"/>
-              <a:buFont typeface="Arial"/>
-              <a:buNone/>
-            </a:pPr>
-            <a:r>
-              <a:rPr lang="en-US"/>
-              <a:t>"Moving to the lifecycle, let's look at how we predict and train. For every instruction, we query both the SVP and the VTAGE tables concurrently. Inside VTAGE, the longest matching history table becomes our 'Provider', and the second-longest becomes the 'Alternate'. If both of those miss, the base SVP acts as our ultimate fallback.</a:t>
-            </a:r>
-            <a:endParaRPr/>
-          </a:p>
-          <a:p>
-            <a:pPr indent="0" lvl="0" marL="0" rtl="0" algn="l">
-              <a:lnSpc>
-                <a:spcPct val="115000"/>
-              </a:lnSpc>
-              <a:spcBef>
-                <a:spcPts val="1200"/>
-              </a:spcBef>
-              <a:spcAft>
-                <a:spcPts val="0"/>
-              </a:spcAft>
-              <a:buClr>
-                <a:schemeClr val="dk1"/>
-              </a:buClr>
-              <a:buSzPts val="1100"/>
-              <a:buFont typeface="Arial"/>
-              <a:buNone/>
-            </a:pPr>
-            <a:r>
-              <a:rPr lang="en-US"/>
-              <a:t>The real engineering happens post-retirement during the Training phase. We don't just blindly increment confidence. We implemented instruction-type-aware stochastic training—meaning Loads and Floating Point operations train twice as fast as generic ALUs. Furthermore, we use the Provider and Alternate predictions to grade usefulness. A VTAGE entry only gains 'usefulness' if it was uniquely correct compared to its alternate, which proves it actually learned a valuable pattern."</a:t>
-            </a:r>
-            <a:endParaRPr/>
-          </a:p>
-          <a:p>
-            <a:pPr indent="0" lvl="0" marL="0" rtl="0" algn="l">
-              <a:spcBef>
-                <a:spcPts val="1200"/>
-              </a:spcBef>
-              <a:spcAft>
-                <a:spcPts val="0"/>
-              </a:spcAft>
-              <a:buNone/>
-            </a:pPr>
-            <a:r>
-              <a:t/>
-            </a:r>
-            <a:endParaRPr/>
-          </a:p>
-        </p:txBody>
-      </p:sp>
-    </p:spTree>
-  </p:cSld>
-  <p:clrMapOvr>
-    <a:masterClrMapping/>
-  </p:clrMapOvr>
-</p:notes>
-</file>
-
-<file path=ppt/notesSlides/notesSlide5.xml><?xml version="1.0" encoding="utf-8"?>
-<p:notes xmlns:a="http://schemas.openxmlformats.org/drawingml/2006/main" xmlns:r="http://schemas.openxmlformats.org/officeDocument/2006/relationships" xmlns:mc="http://schemas.openxmlformats.org/markup-compatibility/2006" xmlns:mv="urn:schemas-microsoft-com:mac:vml" xmlns:p="http://schemas.openxmlformats.org/presentationml/2006/main" xmlns:c="http://schemas.openxmlformats.org/drawingml/2006/chart" xmlns:dgm="http://schemas.openxmlformats.org/drawingml/2006/diagram" xmlns:o="urn:schemas-microsoft-com:office:office" xmlns:v="urn:schemas-microsoft-com:vml" xmlns:pvml="urn:schemas-microsoft-com:office:powerpoint" xmlns:com="http://schemas.openxmlformats.org/drawingml/2006/compatibility" xmlns:p14="http://schemas.microsoft.com/office/powerpoint/2010/main" xmlns:p15="http://schemas.microsoft.com/office/powerpoint/2012/main" xmlns:ahyp="http://schemas.microsoft.com/office/drawing/2018/hyperlinkcolor" showMasterPhAnim="0" showMasterSp="0">
-  <p:cSld>
-    <p:spTree>
-      <p:nvGrpSpPr>
-        <p:cNvPr id="86" name="Shape 86"/>
-        <p:cNvGrpSpPr/>
-        <p:nvPr/>
-      </p:nvGrpSpPr>
-      <p:grpSpPr>
-        <a:xfrm>
-          <a:off x="0" y="0"/>
-          <a:ext cx="0" cy="0"/>
-          <a:chOff x="0" y="0"/>
-          <a:chExt cx="0" cy="0"/>
-        </a:xfrm>
-      </p:grpSpPr>
-      <p:sp>
-        <p:nvSpPr>
-          <p:cNvPr id="87" name="Google Shape;87;g3e073069206_0_60:notes"/>
-          <p:cNvSpPr txBox="1"/>
-          <p:nvPr>
-            <p:ph idx="1" type="body"/>
-          </p:nvPr>
-        </p:nvSpPr>
-        <p:spPr>
-          <a:xfrm>
-            <a:off x="228600" y="4343400"/>
-            <a:ext cx="5486400" cy="4114800"/>
-          </a:xfrm>
-          <a:prstGeom prst="rect">
-            <a:avLst/>
-          </a:prstGeom>
-        </p:spPr>
-        <p:txBody>
-          <a:bodyPr anchorCtr="0" anchor="t" bIns="91425" lIns="91425" spcFirstLastPara="1" rIns="91425" wrap="square" tIns="91425">
-            <a:noAutofit/>
-          </a:bodyPr>
-          <a:lstStyle/>
-          <a:p>
-            <a:pPr indent="0" lvl="0" marL="0" rtl="0" algn="l">
-              <a:lnSpc>
-                <a:spcPct val="115000"/>
-              </a:lnSpc>
-              <a:spcBef>
-                <a:spcPts val="1200"/>
-              </a:spcBef>
-              <a:spcAft>
-                <a:spcPts val="0"/>
-              </a:spcAft>
-              <a:buClr>
-                <a:schemeClr val="dk1"/>
-              </a:buClr>
-              <a:buSzPts val="1100"/>
-              <a:buFont typeface="Arial"/>
-              <a:buNone/>
-            </a:pPr>
-            <a:r>
-              <a:rPr lang="en-US"/>
-              <a:t>"Allocation is where we aggressively protect our hardware capacity. VTAGE only attempts to allocate a new entry if it missed or mispredicted. But we put strict gates on this. We throttle ALU allocations to 1-in-16, and we use a global TICK counter to periodically decay usefulness bits, forcing stale entries to evict.</a:t>
-            </a:r>
-            <a:endParaRPr/>
-          </a:p>
-          <a:p>
-            <a:pPr indent="0" lvl="0" marL="0" rtl="0" algn="l">
-              <a:lnSpc>
-                <a:spcPct val="115000"/>
-              </a:lnSpc>
-              <a:spcBef>
-                <a:spcPts val="1200"/>
-              </a:spcBef>
-              <a:spcAft>
-                <a:spcPts val="0"/>
-              </a:spcAft>
-              <a:buClr>
-                <a:schemeClr val="dk1"/>
-              </a:buClr>
-              <a:buSzPts val="1100"/>
-              <a:buFont typeface="Arial"/>
-              <a:buNone/>
-            </a:pPr>
-            <a:r>
-              <a:rPr lang="en-US"/>
-              <a:t>But our strongest gate is the Allocation Veto. If VTAGE misses, but our SVP base was correct, the SVP hard-vetoes the VTAGE allocation entirely to prevent redundancy.</a:t>
-            </a:r>
-            <a:endParaRPr/>
-          </a:p>
-          <a:p>
-            <a:pPr indent="0" lvl="0" marL="0" rtl="0" algn="l">
-              <a:lnSpc>
-                <a:spcPct val="115000"/>
-              </a:lnSpc>
-              <a:spcBef>
-                <a:spcPts val="1200"/>
-              </a:spcBef>
-              <a:spcAft>
-                <a:spcPts val="0"/>
-              </a:spcAft>
-              <a:buClr>
-                <a:schemeClr val="dk1"/>
-              </a:buClr>
-              <a:buSzPts val="1100"/>
-              <a:buFont typeface="Arial"/>
-              <a:buNone/>
-            </a:pPr>
-            <a:r>
-              <a:rPr lang="en-US"/>
-              <a:t>Finally, if a confident prediction turns out to be wrong, we trigger a rollback. Depending on the severity, this ranges from a partial VPQ rewind to a full pipeline squash where we clear the SVP instances and restore the architectural branch history register to prevent future pollution."</a:t>
-            </a:r>
-            <a:endParaRPr/>
-          </a:p>
-          <a:p>
-            <a:pPr indent="0" lvl="0" marL="0" rtl="0" algn="l">
-              <a:spcBef>
-                <a:spcPts val="1200"/>
-              </a:spcBef>
-              <a:spcAft>
-                <a:spcPts val="0"/>
-              </a:spcAft>
-              <a:buNone/>
-            </a:pPr>
-            <a:r>
-              <a:t/>
-            </a:r>
-            <a:endParaRPr/>
-          </a:p>
-        </p:txBody>
-      </p:sp>
-    </p:spTree>
-  </p:cSld>
-  <p:clrMapOvr>
-    <a:masterClrMapping/>
-  </p:clrMapOvr>
-</p:notes>
-</file>
-
-<file path=ppt/notesSlides/notesSlide6.xml><?xml version="1.0" encoding="utf-8"?>
-<p:notes xmlns:a="http://schemas.openxmlformats.org/drawingml/2006/main" xmlns:r="http://schemas.openxmlformats.org/officeDocument/2006/relationships" xmlns:mc="http://schemas.openxmlformats.org/markup-compatibility/2006" xmlns:mv="urn:schemas-microsoft-com:mac:vml" xmlns:p="http://schemas.openxmlformats.org/presentationml/2006/main" xmlns:c="http://schemas.openxmlformats.org/drawingml/2006/chart" xmlns:dgm="http://schemas.openxmlformats.org/drawingml/2006/diagram" xmlns:o="urn:schemas-microsoft-com:office:office" xmlns:v="urn:schemas-microsoft-com:vml" xmlns:pvml="urn:schemas-microsoft-com:office:powerpoint" xmlns:com="http://schemas.openxmlformats.org/drawingml/2006/compatibility" xmlns:p14="http://schemas.microsoft.com/office/powerpoint/2010/main" xmlns:p15="http://schemas.microsoft.com/office/powerpoint/2012/main" xmlns:ahyp="http://schemas.microsoft.com/office/drawing/2018/hyperlinkcolor" showMasterPhAnim="0" showMasterSp="0">
-  <p:cSld>
-    <p:spTree>
-      <p:nvGrpSpPr>
-        <p:cNvPr id="102" name="Shape 102"/>
-        <p:cNvGrpSpPr/>
-        <p:nvPr/>
-      </p:nvGrpSpPr>
-      <p:grpSpPr>
-        <a:xfrm>
-          <a:off x="0" y="0"/>
-          <a:ext cx="0" cy="0"/>
-          <a:chOff x="0" y="0"/>
-          <a:chExt cx="0" cy="0"/>
-        </a:xfrm>
-      </p:grpSpPr>
-      <p:sp>
-        <p:nvSpPr>
-          <p:cNvPr id="103" name="Google Shape;103;p4:notes"/>
-          <p:cNvSpPr/>
-          <p:nvPr>
-            <p:ph idx="2" type="sldImg"/>
-          </p:nvPr>
-        </p:nvSpPr>
-        <p:spPr>
-          <a:xfrm>
-            <a:off x="0" y="0"/>
-            <a:ext cx="3000000" cy="3000000"/>
-          </a:xfrm>
-          <a:custGeom>
-            <a:rect b="b" l="l" r="r" t="t"/>
-            <a:pathLst>
-              <a:path extrusionOk="0" h="120000" w="120000">
-                <a:moveTo>
-                  <a:pt x="0" y="0"/>
-                </a:moveTo>
-                <a:lnTo>
-                  <a:pt x="120000" y="0"/>
-                </a:lnTo>
-                <a:lnTo>
-                  <a:pt x="120000" y="120000"/>
-                </a:lnTo>
-                <a:lnTo>
-                  <a:pt x="0" y="120000"/>
-                </a:lnTo>
-                <a:close/>
-              </a:path>
-            </a:pathLst>
-          </a:custGeom>
-          <a:noFill/>
-          <a:ln>
-            <a:noFill/>
-          </a:ln>
-        </p:spPr>
-      </p:sp>
-      <p:sp>
-        <p:nvSpPr>
-          <p:cNvPr id="104" name="Google Shape;104;p4:notes"/>
-          <p:cNvSpPr txBox="1"/>
-          <p:nvPr>
-            <p:ph idx="1" type="body"/>
-          </p:nvPr>
-        </p:nvSpPr>
-        <p:spPr>
-          <a:xfrm>
-            <a:off x="0" y="0"/>
-            <a:ext cx="3000000" cy="3000000"/>
-          </a:xfrm>
-          <a:prstGeom prst="rect">
-            <a:avLst/>
-          </a:prstGeom>
-          <a:noFill/>
-          <a:ln>
-            <a:noFill/>
-          </a:ln>
-        </p:spPr>
-        <p:txBody>
-          <a:bodyPr anchorCtr="0" anchor="t" bIns="45700" lIns="91425" spcFirstLastPara="1" rIns="91425" wrap="square" tIns="45700">
-            <a:noAutofit/>
-          </a:bodyPr>
-          <a:lstStyle/>
-          <a:p>
-            <a:pPr indent="0" lvl="0" marL="0" marR="0" rtl="0" algn="l">
-              <a:spcBef>
-                <a:spcPts val="0"/>
-              </a:spcBef>
-              <a:spcAft>
-                <a:spcPts val="0"/>
-              </a:spcAft>
-              <a:buNone/>
-            </a:pPr>
-            <a:r>
-              <a:rPr lang="en-US" sz="1050">
-                <a:solidFill>
-                  <a:srgbClr val="1F1F1F"/>
-                </a:solidFill>
-                <a:highlight>
-                  <a:srgbClr val="FFFFFF"/>
-                </a:highlight>
-                <a:latin typeface="Roboto"/>
-                <a:ea typeface="Roboto"/>
-                <a:cs typeface="Roboto"/>
-                <a:sym typeface="Roboto"/>
-              </a:rPr>
-              <a:t>Regarding the hybrid policy we discussed earlier, we use the modified SVP supremacy policy. This means that whenever SVP is confident we use it’s prediction unless VTAGE is also confident. We also tested SVP Supermacy where SVP always overrides  VTAGE but it was less effective. Regardless, for both policies we list SVP as alternate for allocation blocking </a:t>
-            </a:r>
-            <a:endParaRPr sz="1200">
-              <a:solidFill>
-                <a:schemeClr val="dk1"/>
-              </a:solidFill>
-            </a:endParaRPr>
-          </a:p>
-        </p:txBody>
-      </p:sp>
-      <p:sp>
-        <p:nvSpPr>
-          <p:cNvPr id="105" name="Google Shape;105;p4:notes"/>
-          <p:cNvSpPr txBox="1"/>
-          <p:nvPr>
-            <p:ph idx="12" type="sldNum"/>
-          </p:nvPr>
-        </p:nvSpPr>
-        <p:spPr>
-          <a:xfrm>
-            <a:off x="0" y="0"/>
-            <a:ext cx="3000000" cy="3000000"/>
-          </a:xfrm>
-          <a:prstGeom prst="rect">
-            <a:avLst/>
-          </a:prstGeom>
-          <a:noFill/>
-          <a:ln>
-            <a:noFill/>
-          </a:ln>
-        </p:spPr>
-        <p:txBody>
-          <a:bodyPr anchorCtr="0" anchor="t" bIns="45700" lIns="91425" spcFirstLastPara="1" rIns="91425" wrap="square" tIns="45700">
-            <a:noAutofit/>
-          </a:bodyPr>
-          <a:lstStyle/>
-          <a:p>
-            <a:pPr indent="0" lvl="0" marL="0" marR="0" rtl="0" algn="l">
-              <a:spcBef>
-                <a:spcPts val="0"/>
-              </a:spcBef>
-              <a:spcAft>
-                <a:spcPts val="0"/>
-              </a:spcAft>
-              <a:buNone/>
-            </a:pPr>
-            <a:fld id="{00000000-1234-1234-1234-123412341234}" type="slidenum">
-              <a:rPr lang="en-US" sz="1800">
-                <a:solidFill>
-                  <a:schemeClr val="dk1"/>
-                </a:solidFill>
-                <a:latin typeface="Arial"/>
-                <a:ea typeface="Arial"/>
-                <a:cs typeface="Arial"/>
-                <a:sym typeface="Arial"/>
-              </a:rPr>
-              <a:t>‹#›</a:t>
-            </a:fld>
-            <a:endParaRPr sz="1800">
-              <a:solidFill>
-                <a:schemeClr val="dk1"/>
-              </a:solidFill>
-              <a:latin typeface="Arial"/>
-              <a:ea typeface="Arial"/>
-              <a:cs typeface="Arial"/>
-              <a:sym typeface="Arial"/>
-            </a:endParaRPr>
-          </a:p>
-        </p:txBody>
-      </p:sp>
-    </p:spTree>
-  </p:cSld>
-  <p:clrMapOvr>
-    <a:masterClrMapping/>
-  </p:clrMapOvr>
-</p:notes>
-</file>
-
-<file path=ppt/notesSlides/notesSlide7.xml><?xml version="1.0" encoding="utf-8"?>
-<p:notes xmlns:a="http://schemas.openxmlformats.org/drawingml/2006/main" xmlns:r="http://schemas.openxmlformats.org/officeDocument/2006/relationships" xmlns:mc="http://schemas.openxmlformats.org/markup-compatibility/2006" xmlns:mv="urn:schemas-microsoft-com:mac:vml" xmlns:p="http://schemas.openxmlformats.org/presentationml/2006/main" xmlns:c="http://schemas.openxmlformats.org/drawingml/2006/chart" xmlns:dgm="http://schemas.openxmlformats.org/drawingml/2006/diagram" xmlns:o="urn:schemas-microsoft-com:office:office" xmlns:v="urn:schemas-microsoft-com:vml" xmlns:pvml="urn:schemas-microsoft-com:office:powerpoint" xmlns:com="http://schemas.openxmlformats.org/drawingml/2006/compatibility" xmlns:p14="http://schemas.microsoft.com/office/powerpoint/2010/main" xmlns:p15="http://schemas.microsoft.com/office/powerpoint/2012/main" xmlns:ahyp="http://schemas.microsoft.com/office/drawing/2018/hyperlinkcolor" showMasterPhAnim="0" showMasterSp="0">
-  <p:cSld>
-    <p:spTree>
-      <p:nvGrpSpPr>
-        <p:cNvPr id="129" name="Shape 129"/>
-        <p:cNvGrpSpPr/>
-        <p:nvPr/>
-      </p:nvGrpSpPr>
-      <p:grpSpPr>
-        <a:xfrm>
-          <a:off x="0" y="0"/>
-          <a:ext cx="0" cy="0"/>
-          <a:chOff x="0" y="0"/>
-          <a:chExt cx="0" cy="0"/>
-        </a:xfrm>
-      </p:grpSpPr>
-      <p:sp>
-        <p:nvSpPr>
-          <p:cNvPr id="130" name="Google Shape;130;p5:notes"/>
-          <p:cNvSpPr/>
-          <p:nvPr>
-            <p:ph idx="2" type="sldImg"/>
-          </p:nvPr>
-        </p:nvSpPr>
-        <p:spPr>
-          <a:xfrm>
-            <a:off x="0" y="0"/>
-            <a:ext cx="3000000" cy="3000000"/>
-          </a:xfrm>
-          <a:custGeom>
-            <a:rect b="b" l="l" r="r" t="t"/>
-            <a:pathLst>
-              <a:path extrusionOk="0" h="120000" w="120000">
-                <a:moveTo>
-                  <a:pt x="0" y="0"/>
-                </a:moveTo>
-                <a:lnTo>
-                  <a:pt x="120000" y="0"/>
-                </a:lnTo>
-                <a:lnTo>
-                  <a:pt x="120000" y="120000"/>
-                </a:lnTo>
-                <a:lnTo>
-                  <a:pt x="0" y="120000"/>
-                </a:lnTo>
-                <a:close/>
-              </a:path>
-            </a:pathLst>
-          </a:custGeom>
-          <a:noFill/>
-          <a:ln>
-            <a:noFill/>
-          </a:ln>
-        </p:spPr>
-      </p:sp>
-      <p:sp>
-        <p:nvSpPr>
-          <p:cNvPr id="131" name="Google Shape;131;p5:notes"/>
-          <p:cNvSpPr txBox="1"/>
-          <p:nvPr>
-            <p:ph idx="1" type="body"/>
-          </p:nvPr>
-        </p:nvSpPr>
-        <p:spPr>
-          <a:xfrm>
-            <a:off x="0" y="0"/>
-            <a:ext cx="3000000" cy="3000000"/>
-          </a:xfrm>
-          <a:prstGeom prst="rect">
-            <a:avLst/>
-          </a:prstGeom>
-          <a:noFill/>
-          <a:ln>
-            <a:noFill/>
-          </a:ln>
-        </p:spPr>
-        <p:txBody>
-          <a:bodyPr anchorCtr="0" anchor="t" bIns="45700" lIns="91425" spcFirstLastPara="1" rIns="91425" wrap="square" tIns="45700">
-            <a:noAutofit/>
-          </a:bodyPr>
-          <a:lstStyle/>
-          <a:p>
-            <a:pPr indent="0" lvl="0" marL="0" rtl="0" algn="l">
-              <a:lnSpc>
-                <a:spcPct val="115000"/>
-              </a:lnSpc>
-              <a:spcBef>
-                <a:spcPts val="1200"/>
-              </a:spcBef>
-              <a:spcAft>
-                <a:spcPts val="0"/>
-              </a:spcAft>
-              <a:buClr>
-                <a:schemeClr val="dk1"/>
-              </a:buClr>
-              <a:buSzPts val="1100"/>
-              <a:buFont typeface="Arial"/>
-              <a:buNone/>
-            </a:pPr>
-            <a:r>
-              <a:rPr lang="en-US" sz="1200">
-                <a:solidFill>
-                  <a:schemeClr val="dk1"/>
-                </a:solidFill>
-              </a:rPr>
-              <a:t>"This slide breaks down exactly what we borrowed from Seznec's literature, and how we diverged to get our IPC gains. The blue column covers our foundational baseline: things like TAGE's geometric history lengths and stochastic training.</a:t>
-            </a:r>
-            <a:endParaRPr sz="1200">
-              <a:solidFill>
-                <a:schemeClr val="dk1"/>
-              </a:solidFill>
-            </a:endParaRPr>
-          </a:p>
-          <a:p>
-            <a:pPr indent="0" lvl="0" marL="0" rtl="0" algn="l">
-              <a:lnSpc>
-                <a:spcPct val="115000"/>
-              </a:lnSpc>
-              <a:spcBef>
-                <a:spcPts val="1200"/>
-              </a:spcBef>
-              <a:spcAft>
-                <a:spcPts val="0"/>
-              </a:spcAft>
-              <a:buClr>
-                <a:schemeClr val="dk1"/>
-              </a:buClr>
-              <a:buSzPts val="1100"/>
-              <a:buFont typeface="Arial"/>
-              <a:buNone/>
-            </a:pPr>
-            <a:r>
-              <a:rPr lang="en-US" sz="1200">
-                <a:solidFill>
-                  <a:schemeClr val="dk1"/>
-                </a:solidFill>
-              </a:rPr>
-              <a:t>Our true architectural contributions are in the green and yellow columns. The biggest departure from standard value prediction was porting over TAGE's branch-prediction Alternate logic. We turned the Alternate into a weapon—our Anti-Aliasing SVP Shield blocks VTAGE from evicting established SVP entries, and our Veto prevents redundant allocations.</a:t>
-            </a:r>
-            <a:endParaRPr sz="1200">
-              <a:solidFill>
-                <a:schemeClr val="dk1"/>
-              </a:solidFill>
-            </a:endParaRPr>
-          </a:p>
-          <a:p>
-            <a:pPr indent="0" lvl="0" marL="0" rtl="0" algn="l">
-              <a:lnSpc>
-                <a:spcPct val="115000"/>
-              </a:lnSpc>
-              <a:spcBef>
-                <a:spcPts val="1200"/>
-              </a:spcBef>
-              <a:spcAft>
-                <a:spcPts val="0"/>
-              </a:spcAft>
-              <a:buClr>
-                <a:schemeClr val="dk1"/>
-              </a:buClr>
-              <a:buSzPts val="1100"/>
-              <a:buFont typeface="Arial"/>
-              <a:buNone/>
-            </a:pPr>
-            <a:r>
-              <a:rPr lang="en-US" sz="1200">
-                <a:solidFill>
-                  <a:schemeClr val="dk1"/>
-                </a:solidFill>
-              </a:rPr>
-              <a:t>In the yellow column, you can see our empirical hardware tuning. We capped our Value Prediction Queue at 256 entries to save capacity, and we heavily decoupled our confidence ceilings—forcing VTAGE to hit 63 confident predictions before firing—to perfectly filter out chaotic noise."</a:t>
-            </a:r>
-            <a:endParaRPr sz="1200">
-              <a:solidFill>
-                <a:schemeClr val="dk1"/>
-              </a:solidFill>
-            </a:endParaRPr>
-          </a:p>
-          <a:p>
-            <a:pPr indent="0" lvl="0" marL="0" marR="0" rtl="0" algn="l">
-              <a:spcBef>
-                <a:spcPts val="1200"/>
-              </a:spcBef>
-              <a:spcAft>
-                <a:spcPts val="0"/>
-              </a:spcAft>
-              <a:buNone/>
-            </a:pPr>
-            <a:r>
-              <a:t/>
-            </a:r>
-            <a:endParaRPr sz="1200">
-              <a:solidFill>
-                <a:schemeClr val="dk1"/>
-              </a:solidFill>
-            </a:endParaRPr>
-          </a:p>
-        </p:txBody>
-      </p:sp>
-      <p:sp>
-        <p:nvSpPr>
-          <p:cNvPr id="132" name="Google Shape;132;p5:notes"/>
-          <p:cNvSpPr txBox="1"/>
-          <p:nvPr>
-            <p:ph idx="12" type="sldNum"/>
-          </p:nvPr>
-        </p:nvSpPr>
-        <p:spPr>
-          <a:xfrm>
-            <a:off x="0" y="0"/>
-            <a:ext cx="3000000" cy="3000000"/>
-          </a:xfrm>
-          <a:prstGeom prst="rect">
-            <a:avLst/>
-          </a:prstGeom>
-          <a:noFill/>
-          <a:ln>
-            <a:noFill/>
-          </a:ln>
-        </p:spPr>
-        <p:txBody>
-          <a:bodyPr anchorCtr="0" anchor="t" bIns="45700" lIns="91425" spcFirstLastPara="1" rIns="91425" wrap="square" tIns="45700">
-            <a:noAutofit/>
-          </a:bodyPr>
-          <a:lstStyle/>
-          <a:p>
-            <a:pPr indent="0" lvl="0" marL="0" marR="0" rtl="0" algn="l">
-              <a:spcBef>
-                <a:spcPts val="0"/>
-              </a:spcBef>
-              <a:spcAft>
-                <a:spcPts val="0"/>
-              </a:spcAft>
-              <a:buNone/>
-            </a:pPr>
-            <a:fld id="{00000000-1234-1234-1234-123412341234}" type="slidenum">
-              <a:rPr lang="en-US" sz="1800">
-                <a:solidFill>
-                  <a:schemeClr val="dk1"/>
-                </a:solidFill>
-                <a:latin typeface="Arial"/>
-                <a:ea typeface="Arial"/>
-                <a:cs typeface="Arial"/>
-                <a:sym typeface="Arial"/>
-              </a:rPr>
-              <a:t>‹#›</a:t>
-            </a:fld>
-            <a:endParaRPr sz="1800">
-              <a:solidFill>
-                <a:schemeClr val="dk1"/>
-              </a:solidFill>
-              <a:latin typeface="Arial"/>
-              <a:ea typeface="Arial"/>
-              <a:cs typeface="Arial"/>
-              <a:sym typeface="Arial"/>
-            </a:endParaRPr>
-          </a:p>
-        </p:txBody>
-      </p:sp>
-    </p:spTree>
-  </p:cSld>
-  <p:clrMapOvr>
-    <a:masterClrMapping/>
-  </p:clrMapOvr>
-</p:notes>
-</file>
-
-<file path=ppt/notesSlides/notesSlide8.xml><?xml version="1.0" encoding="utf-8"?>
-<p:notes xmlns:a="http://schemas.openxmlformats.org/drawingml/2006/main" xmlns:r="http://schemas.openxmlformats.org/officeDocument/2006/relationships" xmlns:mc="http://schemas.openxmlformats.org/markup-compatibility/2006" xmlns:mv="urn:schemas-microsoft-com:mac:vml" xmlns:p="http://schemas.openxmlformats.org/presentationml/2006/main" xmlns:c="http://schemas.openxmlformats.org/drawingml/2006/chart" xmlns:dgm="http://schemas.openxmlformats.org/drawingml/2006/diagram" xmlns:o="urn:schemas-microsoft-com:office:office" xmlns:v="urn:schemas-microsoft-com:vml" xmlns:pvml="urn:schemas-microsoft-com:office:powerpoint" xmlns:com="http://schemas.openxmlformats.org/drawingml/2006/compatibility" xmlns:p14="http://schemas.microsoft.com/office/powerpoint/2010/main" xmlns:p15="http://schemas.microsoft.com/office/powerpoint/2012/main" xmlns:ahyp="http://schemas.microsoft.com/office/drawing/2018/hyperlinkcolor" showMasterPhAnim="0" showMasterSp="0">
-  <p:cSld>
-    <p:spTree>
-      <p:nvGrpSpPr>
-        <p:cNvPr id="149" name="Shape 149"/>
-        <p:cNvGrpSpPr/>
-        <p:nvPr/>
-      </p:nvGrpSpPr>
-      <p:grpSpPr>
-        <a:xfrm>
-          <a:off x="0" y="0"/>
-          <a:ext cx="0" cy="0"/>
-          <a:chOff x="0" y="0"/>
-          <a:chExt cx="0" cy="0"/>
-        </a:xfrm>
-      </p:grpSpPr>
-      <p:sp>
-        <p:nvSpPr>
-          <p:cNvPr id="150" name="Google Shape;150;p6:notes"/>
-          <p:cNvSpPr/>
-          <p:nvPr>
-            <p:ph idx="2" type="sldImg"/>
-          </p:nvPr>
-        </p:nvSpPr>
-        <p:spPr>
-          <a:xfrm>
-            <a:off x="0" y="0"/>
-            <a:ext cx="3000000" cy="3000000"/>
-          </a:xfrm>
-          <a:custGeom>
-            <a:rect b="b" l="l" r="r" t="t"/>
-            <a:pathLst>
-              <a:path extrusionOk="0" h="120000" w="120000">
-                <a:moveTo>
-                  <a:pt x="0" y="0"/>
-                </a:moveTo>
-                <a:lnTo>
-                  <a:pt x="120000" y="0"/>
-                </a:lnTo>
-                <a:lnTo>
-                  <a:pt x="120000" y="120000"/>
-                </a:lnTo>
-                <a:lnTo>
-                  <a:pt x="0" y="120000"/>
-                </a:lnTo>
-                <a:close/>
-              </a:path>
-            </a:pathLst>
-          </a:custGeom>
-          <a:noFill/>
-          <a:ln>
-            <a:noFill/>
-          </a:ln>
-        </p:spPr>
-      </p:sp>
-      <p:sp>
-        <p:nvSpPr>
-          <p:cNvPr id="151" name="Google Shape;151;p6:notes"/>
-          <p:cNvSpPr txBox="1"/>
-          <p:nvPr>
-            <p:ph idx="1" type="body"/>
-          </p:nvPr>
-        </p:nvSpPr>
-        <p:spPr>
-          <a:xfrm>
-            <a:off x="0" y="0"/>
-            <a:ext cx="3000000" cy="3000000"/>
-          </a:xfrm>
-          <a:prstGeom prst="rect">
-            <a:avLst/>
-          </a:prstGeom>
-          <a:noFill/>
-          <a:ln>
-            <a:noFill/>
-          </a:ln>
-        </p:spPr>
-        <p:txBody>
-          <a:bodyPr anchorCtr="0" anchor="t" bIns="45700" lIns="91425" spcFirstLastPara="1" rIns="91425" wrap="square" tIns="45700">
-            <a:noAutofit/>
-          </a:bodyPr>
-          <a:lstStyle/>
-          <a:p>
-            <a:pPr indent="0" lvl="0" marL="0" rtl="0" algn="l">
-              <a:spcBef>
-                <a:spcPts val="0"/>
-              </a:spcBef>
-              <a:spcAft>
-                <a:spcPts val="0"/>
-              </a:spcAft>
-              <a:buClr>
-                <a:schemeClr val="dk1"/>
-              </a:buClr>
-              <a:buSzPts val="1100"/>
-              <a:buFont typeface="Arial"/>
-              <a:buNone/>
-            </a:pPr>
-            <a:r>
-              <a:rPr lang="en-US" sz="1050">
-                <a:solidFill>
-                  <a:srgbClr val="1F1F1F"/>
-                </a:solidFill>
-                <a:highlight>
-                  <a:srgbClr val="FFFFFF"/>
-                </a:highlight>
-                <a:latin typeface="Roboto"/>
-                <a:ea typeface="Roboto"/>
-                <a:cs typeface="Roboto"/>
-                <a:sym typeface="Roboto"/>
-              </a:rPr>
-              <a:t>p.</a:t>
-            </a:r>
-            <a:endParaRPr sz="1050">
-              <a:solidFill>
-                <a:srgbClr val="1F1F1F"/>
-              </a:solidFill>
-              <a:highlight>
-                <a:srgbClr val="FFFFFF"/>
-              </a:highlight>
-              <a:latin typeface="Roboto"/>
-              <a:ea typeface="Roboto"/>
-              <a:cs typeface="Roboto"/>
-              <a:sym typeface="Roboto"/>
-            </a:endParaRPr>
-          </a:p>
-          <a:p>
-            <a:pPr indent="-295275" lvl="0" marL="457200" rtl="0" algn="l">
-              <a:lnSpc>
-                <a:spcPct val="115000"/>
-              </a:lnSpc>
-              <a:spcBef>
-                <a:spcPts val="1200"/>
-              </a:spcBef>
-              <a:spcAft>
-                <a:spcPts val="0"/>
-              </a:spcAft>
-              <a:buClr>
-                <a:srgbClr val="1F1F1F"/>
-              </a:buClr>
-              <a:buSzPts val="1050"/>
-              <a:buFont typeface="Roboto"/>
-              <a:buChar char="●"/>
-            </a:pPr>
-            <a:r>
-              <a:rPr b="1" lang="en-US" sz="1050">
-                <a:solidFill>
-                  <a:srgbClr val="1F1F1F"/>
-                </a:solidFill>
-                <a:highlight>
-                  <a:srgbClr val="FFFFFF"/>
-                </a:highlight>
-                <a:latin typeface="Roboto"/>
-                <a:ea typeface="Roboto"/>
-                <a:cs typeface="Roboto"/>
-                <a:sym typeface="Roboto"/>
-              </a:rPr>
-              <a:t>SVP Conf Max (47):</a:t>
-            </a:r>
-            <a:r>
-              <a:rPr lang="en-US" sz="1050">
-                <a:solidFill>
-                  <a:srgbClr val="1F1F1F"/>
-                </a:solidFill>
-                <a:highlight>
-                  <a:srgbClr val="FFFFFF"/>
-                </a:highlight>
-                <a:latin typeface="Roboto"/>
-                <a:ea typeface="Roboto"/>
-                <a:cs typeface="Roboto"/>
-                <a:sym typeface="Roboto"/>
-              </a:rPr>
-              <a:t> We set the Stride Value Predictor's maximum confidence at 47. This allows the SVP to fire sooner, which is crucial for structured workloads like </a:t>
-            </a:r>
-            <a:r>
-              <a:rPr lang="en-US" sz="1050">
-                <a:solidFill>
-                  <a:srgbClr val="444746"/>
-                </a:solidFill>
-                <a:highlight>
-                  <a:srgbClr val="DDE3EA"/>
-                </a:highlight>
-                <a:latin typeface="Courier New"/>
-                <a:ea typeface="Courier New"/>
-                <a:cs typeface="Courier New"/>
-                <a:sym typeface="Courier New"/>
-              </a:rPr>
-              <a:t>perlbench</a:t>
-            </a:r>
-            <a:r>
-              <a:rPr lang="en-US" sz="1050">
-                <a:solidFill>
-                  <a:srgbClr val="1F1F1F"/>
-                </a:solidFill>
-                <a:highlight>
-                  <a:srgbClr val="FFFFFF"/>
-                </a:highlight>
-                <a:latin typeface="Roboto"/>
-                <a:ea typeface="Roboto"/>
-                <a:cs typeface="Roboto"/>
-                <a:sym typeface="Roboto"/>
-              </a:rPr>
-              <a:t> and </a:t>
-            </a:r>
-            <a:r>
-              <a:rPr lang="en-US" sz="1050">
-                <a:solidFill>
-                  <a:srgbClr val="444746"/>
-                </a:solidFill>
-                <a:highlight>
-                  <a:srgbClr val="DDE3EA"/>
-                </a:highlight>
-                <a:latin typeface="Courier New"/>
-                <a:ea typeface="Courier New"/>
-                <a:cs typeface="Courier New"/>
-                <a:sym typeface="Courier New"/>
-              </a:rPr>
-              <a:t>h264ref</a:t>
-            </a:r>
-            <a:r>
-              <a:rPr lang="en-US" sz="1050">
-                <a:solidFill>
-                  <a:srgbClr val="1F1F1F"/>
-                </a:solidFill>
-                <a:highlight>
-                  <a:srgbClr val="FFFFFF"/>
-                </a:highlight>
-                <a:latin typeface="Roboto"/>
-                <a:ea typeface="Roboto"/>
-                <a:cs typeface="Roboto"/>
-                <a:sym typeface="Roboto"/>
-              </a:rPr>
-              <a:t> where simple stride patterns are highly accurate.</a:t>
-            </a:r>
-            <a:endParaRPr sz="1050">
-              <a:solidFill>
-                <a:srgbClr val="1F1F1F"/>
-              </a:solidFill>
-              <a:highlight>
-                <a:srgbClr val="FFFFFF"/>
-              </a:highlight>
-              <a:latin typeface="Roboto"/>
-              <a:ea typeface="Roboto"/>
-              <a:cs typeface="Roboto"/>
-              <a:sym typeface="Roboto"/>
-            </a:endParaRPr>
-          </a:p>
-          <a:p>
-            <a:pPr indent="-295275" lvl="0" marL="457200" rtl="0" algn="l">
-              <a:lnSpc>
-                <a:spcPct val="115000"/>
-              </a:lnSpc>
-              <a:spcBef>
-                <a:spcPts val="0"/>
-              </a:spcBef>
-              <a:spcAft>
-                <a:spcPts val="0"/>
-              </a:spcAft>
-              <a:buClr>
-                <a:srgbClr val="1F1F1F"/>
-              </a:buClr>
-              <a:buSzPts val="1050"/>
-              <a:buFont typeface="Roboto"/>
-              <a:buChar char="●"/>
-            </a:pPr>
-            <a:r>
-              <a:rPr b="1" lang="en-US" sz="1050">
-                <a:solidFill>
-                  <a:srgbClr val="1F1F1F"/>
-                </a:solidFill>
-                <a:highlight>
-                  <a:srgbClr val="FFFFFF"/>
-                </a:highlight>
-                <a:latin typeface="Roboto"/>
-                <a:ea typeface="Roboto"/>
-                <a:cs typeface="Roboto"/>
-                <a:sym typeface="Roboto"/>
-              </a:rPr>
-              <a:t>VTAGE Configuration:</a:t>
-            </a:r>
-            <a:r>
-              <a:rPr lang="en-US" sz="1050">
-                <a:solidFill>
-                  <a:srgbClr val="1F1F1F"/>
-                </a:solidFill>
-                <a:highlight>
-                  <a:srgbClr val="FFFFFF"/>
-                </a:highlight>
-                <a:latin typeface="Roboto"/>
-                <a:ea typeface="Roboto"/>
-                <a:cs typeface="Roboto"/>
-                <a:sym typeface="Roboto"/>
-              </a:rPr>
-              <a:t> For the VTAGE predictor, we use </a:t>
-            </a:r>
-            <a:r>
-              <a:rPr b="1" lang="en-US" sz="1050">
-                <a:solidFill>
-                  <a:srgbClr val="1F1F1F"/>
-                </a:solidFill>
-                <a:highlight>
-                  <a:srgbClr val="FFFFFF"/>
-                </a:highlight>
-                <a:latin typeface="Roboto"/>
-                <a:ea typeface="Roboto"/>
-                <a:cs typeface="Roboto"/>
-                <a:sym typeface="Roboto"/>
-              </a:rPr>
-              <a:t>5 tables</a:t>
-            </a:r>
-            <a:r>
-              <a:rPr lang="en-US" sz="1050">
-                <a:solidFill>
-                  <a:srgbClr val="1F1F1F"/>
-                </a:solidFill>
-                <a:highlight>
-                  <a:srgbClr val="FFFFFF"/>
-                </a:highlight>
-                <a:latin typeface="Roboto"/>
-                <a:ea typeface="Roboto"/>
-                <a:cs typeface="Roboto"/>
-                <a:sym typeface="Roboto"/>
-              </a:rPr>
-              <a:t> with geometrically spaced history lengths ranging from a </a:t>
-            </a:r>
-            <a:r>
-              <a:rPr b="1" lang="en-US" sz="1050">
-                <a:solidFill>
-                  <a:srgbClr val="1F1F1F"/>
-                </a:solidFill>
-                <a:highlight>
-                  <a:srgbClr val="FFFFFF"/>
-                </a:highlight>
-                <a:latin typeface="Roboto"/>
-                <a:ea typeface="Roboto"/>
-                <a:cs typeface="Roboto"/>
-                <a:sym typeface="Roboto"/>
-              </a:rPr>
-              <a:t>minimum of 3 branches</a:t>
-            </a:r>
-            <a:r>
-              <a:rPr lang="en-US" sz="1050">
-                <a:solidFill>
-                  <a:srgbClr val="1F1F1F"/>
-                </a:solidFill>
-                <a:highlight>
-                  <a:srgbClr val="FFFFFF"/>
-                </a:highlight>
-                <a:latin typeface="Roboto"/>
-                <a:ea typeface="Roboto"/>
-                <a:cs typeface="Roboto"/>
-                <a:sym typeface="Roboto"/>
-              </a:rPr>
-              <a:t> to a </a:t>
-            </a:r>
-            <a:r>
-              <a:rPr b="1" lang="en-US" sz="1050">
-                <a:solidFill>
-                  <a:srgbClr val="1F1F1F"/>
-                </a:solidFill>
-                <a:highlight>
-                  <a:srgbClr val="FFFFFF"/>
-                </a:highlight>
-                <a:latin typeface="Roboto"/>
-                <a:ea typeface="Roboto"/>
-                <a:cs typeface="Roboto"/>
-                <a:sym typeface="Roboto"/>
-              </a:rPr>
-              <a:t>maximum of 54 branches</a:t>
-            </a:r>
-            <a:r>
-              <a:rPr lang="en-US" sz="1050">
-                <a:solidFill>
-                  <a:srgbClr val="1F1F1F"/>
-                </a:solidFill>
-                <a:highlight>
-                  <a:srgbClr val="FFFFFF"/>
-                </a:highlight>
-                <a:latin typeface="Roboto"/>
-                <a:ea typeface="Roboto"/>
-                <a:cs typeface="Roboto"/>
-                <a:sym typeface="Roboto"/>
-              </a:rPr>
-              <a:t>. This provides excellent coverage from short innermost loops to longer, function-level execution context.</a:t>
-            </a:r>
-            <a:endParaRPr sz="1050">
-              <a:solidFill>
-                <a:srgbClr val="1F1F1F"/>
-              </a:solidFill>
-              <a:highlight>
-                <a:srgbClr val="FFFFFF"/>
-              </a:highlight>
-              <a:latin typeface="Roboto"/>
-              <a:ea typeface="Roboto"/>
-              <a:cs typeface="Roboto"/>
-              <a:sym typeface="Roboto"/>
-            </a:endParaRPr>
-          </a:p>
-          <a:p>
-            <a:pPr indent="-295275" lvl="0" marL="457200" rtl="0" algn="l">
-              <a:lnSpc>
-                <a:spcPct val="115000"/>
-              </a:lnSpc>
-              <a:spcBef>
-                <a:spcPts val="0"/>
-              </a:spcBef>
-              <a:spcAft>
-                <a:spcPts val="0"/>
-              </a:spcAft>
-              <a:buClr>
-                <a:srgbClr val="1F1F1F"/>
-              </a:buClr>
-              <a:buSzPts val="1050"/>
-              <a:buFont typeface="Roboto"/>
-              <a:buChar char="●"/>
-            </a:pPr>
-            <a:r>
-              <a:rPr b="1" lang="en-US" sz="1050">
-                <a:solidFill>
-                  <a:srgbClr val="1F1F1F"/>
-                </a:solidFill>
-                <a:highlight>
-                  <a:srgbClr val="FFFFFF"/>
-                </a:highlight>
-                <a:latin typeface="Roboto"/>
-                <a:ea typeface="Roboto"/>
-                <a:cs typeface="Roboto"/>
-                <a:sym typeface="Roboto"/>
-              </a:rPr>
-              <a:t>VTAGE Conf Max (63):</a:t>
-            </a:r>
-            <a:r>
-              <a:rPr lang="en-US" sz="1050">
-                <a:solidFill>
-                  <a:srgbClr val="1F1F1F"/>
-                </a:solidFill>
-                <a:highlight>
-                  <a:srgbClr val="FFFFFF"/>
-                </a:highlight>
-                <a:latin typeface="Roboto"/>
-                <a:ea typeface="Roboto"/>
-                <a:cs typeface="Roboto"/>
-                <a:sym typeface="Roboto"/>
-              </a:rPr>
-              <a:t> Crucially, we set the VTAGE maximum confidence to a high bar of 63. This means a VTAGE entry must prove itself with 63 or more correct predictions before it is considered fully confident, acting as a robust misprediction filter.</a:t>
-            </a:r>
-            <a:endParaRPr sz="1050">
-              <a:solidFill>
-                <a:srgbClr val="1F1F1F"/>
-              </a:solidFill>
-              <a:highlight>
-                <a:srgbClr val="FFFFFF"/>
-              </a:highlight>
-              <a:latin typeface="Roboto"/>
-              <a:ea typeface="Roboto"/>
-              <a:cs typeface="Roboto"/>
-              <a:sym typeface="Roboto"/>
-            </a:endParaRPr>
-          </a:p>
-          <a:p>
-            <a:pPr indent="-295275" lvl="0" marL="457200" rtl="0" algn="l">
-              <a:lnSpc>
-                <a:spcPct val="115000"/>
-              </a:lnSpc>
-              <a:spcBef>
-                <a:spcPts val="0"/>
-              </a:spcBef>
-              <a:spcAft>
-                <a:spcPts val="0"/>
-              </a:spcAft>
-              <a:buClr>
-                <a:srgbClr val="1F1F1F"/>
-              </a:buClr>
-              <a:buSzPts val="1050"/>
-              <a:buFont typeface="Roboto"/>
-              <a:buChar char="●"/>
-            </a:pPr>
-            <a:r>
-              <a:rPr b="1" lang="en-US" sz="1050">
-                <a:solidFill>
-                  <a:srgbClr val="1F1F1F"/>
-                </a:solidFill>
-                <a:highlight>
-                  <a:srgbClr val="FFFFFF"/>
-                </a:highlight>
-                <a:latin typeface="Roboto"/>
-                <a:ea typeface="Roboto"/>
-                <a:cs typeface="Roboto"/>
-                <a:sym typeface="Roboto"/>
-              </a:rPr>
-              <a:t>Storage Budget:</a:t>
-            </a:r>
-            <a:r>
-              <a:rPr lang="en-US" sz="1050">
-                <a:solidFill>
-                  <a:srgbClr val="1F1F1F"/>
-                </a:solidFill>
-                <a:highlight>
-                  <a:srgbClr val="FFFFFF"/>
-                </a:highlight>
-                <a:latin typeface="Roboto"/>
-                <a:ea typeface="Roboto"/>
-                <a:cs typeface="Roboto"/>
-                <a:sym typeface="Roboto"/>
-              </a:rPr>
-              <a:t> The final configuration is highly optimized for capacity. The SVP uses approximately 19 KB, and the five VTAGE tables use about 13 KB, bringing our </a:t>
-            </a:r>
-            <a:r>
-              <a:rPr b="1" lang="en-US" sz="1050">
-                <a:solidFill>
-                  <a:srgbClr val="1F1F1F"/>
-                </a:solidFill>
-                <a:highlight>
-                  <a:srgbClr val="FFFFFF"/>
-                </a:highlight>
-                <a:latin typeface="Roboto"/>
-                <a:ea typeface="Roboto"/>
-                <a:cs typeface="Roboto"/>
-                <a:sym typeface="Roboto"/>
-              </a:rPr>
-              <a:t>Total Storage to 31.97 KB</a:t>
-            </a:r>
-            <a:r>
-              <a:rPr lang="en-US" sz="1050">
-                <a:solidFill>
-                  <a:srgbClr val="1F1F1F"/>
-                </a:solidFill>
-                <a:highlight>
-                  <a:srgbClr val="FFFFFF"/>
-                </a:highlight>
-                <a:latin typeface="Roboto"/>
-                <a:ea typeface="Roboto"/>
-                <a:cs typeface="Roboto"/>
-                <a:sym typeface="Roboto"/>
-              </a:rPr>
-              <a:t>, successfully keeping us under the 32 KB budget."</a:t>
-            </a:r>
-            <a:endParaRPr sz="1050">
-              <a:solidFill>
-                <a:srgbClr val="1F1F1F"/>
-              </a:solidFill>
-              <a:highlight>
-                <a:srgbClr val="FFFFFF"/>
-              </a:highlight>
-              <a:latin typeface="Roboto"/>
-              <a:ea typeface="Roboto"/>
-              <a:cs typeface="Roboto"/>
-              <a:sym typeface="Roboto"/>
-            </a:endParaRPr>
-          </a:p>
-          <a:p>
-            <a:pPr indent="0" lvl="0" marL="0" marR="0" rtl="0" algn="l">
-              <a:spcBef>
-                <a:spcPts val="1200"/>
-              </a:spcBef>
-              <a:spcAft>
-                <a:spcPts val="0"/>
-              </a:spcAft>
-              <a:buNone/>
-            </a:pPr>
-            <a:r>
-              <a:t/>
-            </a:r>
-            <a:endParaRPr sz="1200">
-              <a:solidFill>
-                <a:schemeClr val="dk1"/>
-              </a:solidFill>
-            </a:endParaRPr>
-          </a:p>
-        </p:txBody>
-      </p:sp>
-      <p:sp>
-        <p:nvSpPr>
-          <p:cNvPr id="152" name="Google Shape;152;p6:notes"/>
-          <p:cNvSpPr txBox="1"/>
-          <p:nvPr>
-            <p:ph idx="12" type="sldNum"/>
-          </p:nvPr>
-        </p:nvSpPr>
-        <p:spPr>
-          <a:xfrm>
-            <a:off x="0" y="0"/>
-            <a:ext cx="3000000" cy="3000000"/>
-          </a:xfrm>
-          <a:prstGeom prst="rect">
-            <a:avLst/>
-          </a:prstGeom>
-          <a:noFill/>
-          <a:ln>
-            <a:noFill/>
-          </a:ln>
-        </p:spPr>
-        <p:txBody>
-          <a:bodyPr anchorCtr="0" anchor="t" bIns="45700" lIns="91425" spcFirstLastPara="1" rIns="91425" wrap="square" tIns="45700">
-            <a:noAutofit/>
-          </a:bodyPr>
-          <a:lstStyle/>
-          <a:p>
-            <a:pPr indent="0" lvl="0" marL="0" marR="0" rtl="0" algn="l">
-              <a:spcBef>
-                <a:spcPts val="0"/>
-              </a:spcBef>
-              <a:spcAft>
-                <a:spcPts val="0"/>
-              </a:spcAft>
-              <a:buNone/>
-            </a:pPr>
-            <a:fld id="{00000000-1234-1234-1234-123412341234}" type="slidenum">
-              <a:rPr lang="en-US" sz="1800">
-                <a:solidFill>
-                  <a:schemeClr val="dk1"/>
-                </a:solidFill>
-                <a:latin typeface="Arial"/>
-                <a:ea typeface="Arial"/>
-                <a:cs typeface="Arial"/>
-                <a:sym typeface="Arial"/>
-              </a:rPr>
-              <a:t>‹#›</a:t>
-            </a:fld>
-            <a:endParaRPr sz="1800">
-              <a:solidFill>
-                <a:schemeClr val="dk1"/>
-              </a:solidFill>
-              <a:latin typeface="Arial"/>
-              <a:ea typeface="Arial"/>
-              <a:cs typeface="Arial"/>
-              <a:sym typeface="Arial"/>
-            </a:endParaRPr>
-          </a:p>
-        </p:txBody>
-      </p:sp>
-    </p:spTree>
-  </p:cSld>
-  <p:clrMapOvr>
-    <a:masterClrMapping/>
-  </p:clrMapOvr>
-</p:notes>
-</file>
-
-<file path=ppt/notesSlides/notesSlide9.xml><?xml version="1.0" encoding="utf-8"?>
-<p:notes xmlns:a="http://schemas.openxmlformats.org/drawingml/2006/main" xmlns:r="http://schemas.openxmlformats.org/officeDocument/2006/relationships" xmlns:mc="http://schemas.openxmlformats.org/markup-compatibility/2006" xmlns:mv="urn:schemas-microsoft-com:mac:vml" xmlns:p="http://schemas.openxmlformats.org/presentationml/2006/main" xmlns:c="http://schemas.openxmlformats.org/drawingml/2006/chart" xmlns:dgm="http://schemas.openxmlformats.org/drawingml/2006/diagram" xmlns:o="urn:schemas-microsoft-com:office:office" xmlns:v="urn:schemas-microsoft-com:vml" xmlns:pvml="urn:schemas-microsoft-com:office:powerpoint" xmlns:com="http://schemas.openxmlformats.org/drawingml/2006/compatibility" xmlns:p14="http://schemas.microsoft.com/office/powerpoint/2010/main" xmlns:p15="http://schemas.microsoft.com/office/powerpoint/2012/main" xmlns:ahyp="http://schemas.microsoft.com/office/drawing/2018/hyperlinkcolor" showMasterPhAnim="0" showMasterSp="0">
-  <p:cSld>
-    <p:spTree>
-      <p:nvGrpSpPr>
-        <p:cNvPr id="205" name="Shape 205"/>
-        <p:cNvGrpSpPr/>
-        <p:nvPr/>
-      </p:nvGrpSpPr>
-      <p:grpSpPr>
-        <a:xfrm>
-          <a:off x="0" y="0"/>
-          <a:ext cx="0" cy="0"/>
-          <a:chOff x="0" y="0"/>
-          <a:chExt cx="0" cy="0"/>
-        </a:xfrm>
-      </p:grpSpPr>
-      <p:sp>
-        <p:nvSpPr>
-          <p:cNvPr id="206" name="Google Shape;206;p7:notes"/>
-          <p:cNvSpPr/>
-          <p:nvPr>
-            <p:ph idx="2" type="sldImg"/>
-          </p:nvPr>
-        </p:nvSpPr>
-        <p:spPr>
-          <a:xfrm>
-            <a:off x="0" y="0"/>
-            <a:ext cx="3000000" cy="3000000"/>
-          </a:xfrm>
-          <a:custGeom>
-            <a:rect b="b" l="l" r="r" t="t"/>
-            <a:pathLst>
-              <a:path extrusionOk="0" h="120000" w="120000">
-                <a:moveTo>
-                  <a:pt x="0" y="0"/>
-                </a:moveTo>
-                <a:lnTo>
-                  <a:pt x="120000" y="0"/>
-                </a:lnTo>
-                <a:lnTo>
-                  <a:pt x="120000" y="120000"/>
-                </a:lnTo>
-                <a:lnTo>
-                  <a:pt x="0" y="120000"/>
-                </a:lnTo>
-                <a:close/>
-              </a:path>
-            </a:pathLst>
-          </a:custGeom>
-          <a:noFill/>
-          <a:ln>
-            <a:noFill/>
-          </a:ln>
-        </p:spPr>
-      </p:sp>
-      <p:sp>
-        <p:nvSpPr>
-          <p:cNvPr id="207" name="Google Shape;207;p7:notes"/>
-          <p:cNvSpPr txBox="1"/>
-          <p:nvPr>
-            <p:ph idx="1" type="body"/>
-          </p:nvPr>
-        </p:nvSpPr>
-        <p:spPr>
-          <a:xfrm>
-            <a:off x="0" y="0"/>
-            <a:ext cx="3000000" cy="3000000"/>
-          </a:xfrm>
-          <a:prstGeom prst="rect">
-            <a:avLst/>
-          </a:prstGeom>
-          <a:noFill/>
-          <a:ln>
-            <a:noFill/>
-          </a:ln>
-        </p:spPr>
-        <p:txBody>
-          <a:bodyPr anchorCtr="0" anchor="t" bIns="45700" lIns="91425" spcFirstLastPara="1" rIns="91425" wrap="square" tIns="45700">
-            <a:noAutofit/>
-          </a:bodyPr>
-          <a:lstStyle/>
-          <a:p>
-            <a:pPr indent="0" lvl="0" marL="0" rtl="0" algn="l">
-              <a:spcBef>
-                <a:spcPts val="0"/>
-              </a:spcBef>
-              <a:spcAft>
-                <a:spcPts val="0"/>
-              </a:spcAft>
-              <a:buClr>
-                <a:schemeClr val="dk1"/>
-              </a:buClr>
-              <a:buSzPts val="1100"/>
-              <a:buFont typeface="Arial"/>
-              <a:buNone/>
-            </a:pPr>
-            <a:r>
-              <a:t/>
-            </a:r>
-            <a:endParaRPr sz="1200">
-              <a:solidFill>
-                <a:schemeClr val="dk1"/>
-              </a:solidFill>
-            </a:endParaRPr>
-          </a:p>
-          <a:p>
-            <a:pPr indent="0" lvl="0" marL="0" rtl="0" algn="l">
-              <a:spcBef>
-                <a:spcPts val="0"/>
-              </a:spcBef>
-              <a:spcAft>
-                <a:spcPts val="0"/>
-              </a:spcAft>
-              <a:buClr>
-                <a:schemeClr val="dk1"/>
-              </a:buClr>
-              <a:buSzPts val="1100"/>
-              <a:buFont typeface="Arial"/>
-              <a:buNone/>
-            </a:pPr>
-            <a:r>
-              <a:rPr lang="en-US" sz="1050">
-                <a:solidFill>
-                  <a:srgbClr val="1F1F1F"/>
-                </a:solidFill>
-                <a:highlight>
-                  <a:srgbClr val="FFFFFF"/>
-                </a:highlight>
-                <a:latin typeface="Roboto"/>
-                <a:ea typeface="Roboto"/>
-                <a:cs typeface="Roboto"/>
-                <a:sym typeface="Roboto"/>
-              </a:rPr>
-              <a:t>"The results of our championship run are summarized here. Our final configuration achieved a </a:t>
-            </a:r>
-            <a:r>
-              <a:rPr b="1" lang="en-US" sz="1050">
-                <a:solidFill>
-                  <a:srgbClr val="1F1F1F"/>
-                </a:solidFill>
-                <a:highlight>
-                  <a:srgbClr val="FFFFFF"/>
-                </a:highlight>
-                <a:latin typeface="Roboto"/>
-                <a:ea typeface="Roboto"/>
-                <a:cs typeface="Roboto"/>
-                <a:sym typeface="Roboto"/>
-              </a:rPr>
-              <a:t>Harmonic Mean IPC of 2.054</a:t>
-            </a:r>
-            <a:r>
-              <a:rPr lang="en-US" sz="1050">
-                <a:solidFill>
-                  <a:srgbClr val="1F1F1F"/>
-                </a:solidFill>
-                <a:highlight>
-                  <a:srgbClr val="FFFFFF"/>
-                </a:highlight>
-                <a:latin typeface="Roboto"/>
-                <a:ea typeface="Roboto"/>
-                <a:cs typeface="Roboto"/>
-                <a:sym typeface="Roboto"/>
-              </a:rPr>
-              <a:t> against the baseline of 1.66, representing a substantial gain of approximately 24%.</a:t>
-            </a:r>
-            <a:endParaRPr sz="1050">
-              <a:solidFill>
-                <a:srgbClr val="1F1F1F"/>
-              </a:solidFill>
-              <a:highlight>
-                <a:srgbClr val="FFFFFF"/>
-              </a:highlight>
-              <a:latin typeface="Roboto"/>
-              <a:ea typeface="Roboto"/>
-              <a:cs typeface="Roboto"/>
-              <a:sym typeface="Roboto"/>
-            </a:endParaRPr>
-          </a:p>
-          <a:p>
-            <a:pPr indent="-295275" lvl="0" marL="457200" rtl="0" algn="l">
-              <a:lnSpc>
-                <a:spcPct val="115000"/>
-              </a:lnSpc>
-              <a:spcBef>
-                <a:spcPts val="1200"/>
-              </a:spcBef>
-              <a:spcAft>
-                <a:spcPts val="0"/>
-              </a:spcAft>
-              <a:buClr>
-                <a:srgbClr val="1F1F1F"/>
-              </a:buClr>
-              <a:buSzPts val="1050"/>
-              <a:buFont typeface="Roboto"/>
-              <a:buChar char="●"/>
-            </a:pPr>
-            <a:r>
-              <a:rPr b="1" lang="en-US" sz="1050">
-                <a:solidFill>
-                  <a:srgbClr val="1F1F1F"/>
-                </a:solidFill>
-                <a:highlight>
-                  <a:srgbClr val="FFFFFF"/>
-                </a:highlight>
-                <a:latin typeface="Roboto"/>
-                <a:ea typeface="Roboto"/>
-                <a:cs typeface="Roboto"/>
-                <a:sym typeface="Roboto"/>
-              </a:rPr>
-              <a:t>Structured Workloads:</a:t>
-            </a:r>
-            <a:r>
-              <a:rPr lang="en-US" sz="1050">
-                <a:solidFill>
-                  <a:srgbClr val="1F1F1F"/>
-                </a:solidFill>
-                <a:highlight>
-                  <a:srgbClr val="FFFFFF"/>
-                </a:highlight>
-                <a:latin typeface="Roboto"/>
-                <a:ea typeface="Roboto"/>
-                <a:cs typeface="Roboto"/>
-                <a:sym typeface="Roboto"/>
-              </a:rPr>
-              <a:t> We saw strong gains in structured workloads, such as a </a:t>
-            </a:r>
-            <a:r>
-              <a:rPr b="1" lang="en-US" sz="1050">
-                <a:solidFill>
-                  <a:srgbClr val="1F1F1F"/>
-                </a:solidFill>
-                <a:highlight>
-                  <a:srgbClr val="FFFFFF"/>
-                </a:highlight>
-                <a:latin typeface="Roboto"/>
-                <a:ea typeface="Roboto"/>
-                <a:cs typeface="Roboto"/>
-                <a:sym typeface="Roboto"/>
-              </a:rPr>
-              <a:t>12.4% boost for </a:t>
-            </a:r>
-            <a:r>
-              <a:rPr lang="en-US" sz="1050">
-                <a:solidFill>
-                  <a:srgbClr val="444746"/>
-                </a:solidFill>
-                <a:highlight>
-                  <a:srgbClr val="DDE3EA"/>
-                </a:highlight>
-                <a:latin typeface="Courier New"/>
-                <a:ea typeface="Courier New"/>
-                <a:cs typeface="Courier New"/>
-                <a:sym typeface="Courier New"/>
-              </a:rPr>
-              <a:t>perlbench</a:t>
-            </a:r>
-            <a:r>
-              <a:rPr lang="en-US" sz="1050">
-                <a:solidFill>
-                  <a:srgbClr val="1F1F1F"/>
-                </a:solidFill>
-                <a:highlight>
-                  <a:srgbClr val="FFFFFF"/>
-                </a:highlight>
-                <a:latin typeface="Roboto"/>
-                <a:ea typeface="Roboto"/>
-                <a:cs typeface="Roboto"/>
-                <a:sym typeface="Roboto"/>
-              </a:rPr>
-              <a:t>, increasing its IPC from 5.01 to 5.63.</a:t>
-            </a:r>
-            <a:endParaRPr sz="1050">
-              <a:solidFill>
-                <a:srgbClr val="1F1F1F"/>
-              </a:solidFill>
-              <a:highlight>
-                <a:srgbClr val="FFFFFF"/>
-              </a:highlight>
-              <a:latin typeface="Roboto"/>
-              <a:ea typeface="Roboto"/>
-              <a:cs typeface="Roboto"/>
-              <a:sym typeface="Roboto"/>
-            </a:endParaRPr>
-          </a:p>
-          <a:p>
-            <a:pPr indent="-295275" lvl="0" marL="457200" rtl="0" algn="l">
-              <a:lnSpc>
-                <a:spcPct val="115000"/>
-              </a:lnSpc>
-              <a:spcBef>
-                <a:spcPts val="0"/>
-              </a:spcBef>
-              <a:spcAft>
-                <a:spcPts val="0"/>
-              </a:spcAft>
-              <a:buClr>
-                <a:srgbClr val="1F1F1F"/>
-              </a:buClr>
-              <a:buSzPts val="1050"/>
-              <a:buFont typeface="Roboto"/>
-              <a:buChar char="●"/>
-            </a:pPr>
-            <a:r>
-              <a:rPr b="1" lang="en-US" sz="1050">
-                <a:solidFill>
-                  <a:srgbClr val="1F1F1F"/>
-                </a:solidFill>
-                <a:highlight>
-                  <a:srgbClr val="FFFFFF"/>
-                </a:highlight>
-                <a:latin typeface="Roboto"/>
-                <a:ea typeface="Roboto"/>
-                <a:cs typeface="Roboto"/>
-                <a:sym typeface="Roboto"/>
-              </a:rPr>
-              <a:t>Memory Workloads:</a:t>
-            </a:r>
-            <a:r>
-              <a:rPr lang="en-US" sz="1050">
-                <a:solidFill>
-                  <a:srgbClr val="1F1F1F"/>
-                </a:solidFill>
-                <a:highlight>
-                  <a:srgbClr val="FFFFFF"/>
-                </a:highlight>
-                <a:latin typeface="Roboto"/>
-                <a:ea typeface="Roboto"/>
-                <a:cs typeface="Roboto"/>
-                <a:sym typeface="Roboto"/>
-              </a:rPr>
-              <a:t> Our hybrid predictor was particularly effective on the memory-intensive workload </a:t>
-            </a:r>
-            <a:r>
-              <a:rPr lang="en-US" sz="1050">
-                <a:solidFill>
-                  <a:srgbClr val="444746"/>
-                </a:solidFill>
-                <a:highlight>
-                  <a:srgbClr val="DDE3EA"/>
-                </a:highlight>
-                <a:latin typeface="Courier New"/>
-                <a:ea typeface="Courier New"/>
-                <a:cs typeface="Courier New"/>
-                <a:sym typeface="Courier New"/>
-              </a:rPr>
-              <a:t>mcf</a:t>
-            </a:r>
-            <a:r>
-              <a:rPr lang="en-US" sz="1050">
-                <a:solidFill>
-                  <a:srgbClr val="1F1F1F"/>
-                </a:solidFill>
-                <a:highlight>
-                  <a:srgbClr val="FFFFFF"/>
-                </a:highlight>
-                <a:latin typeface="Roboto"/>
-                <a:ea typeface="Roboto"/>
-                <a:cs typeface="Roboto"/>
-                <a:sym typeface="Roboto"/>
-              </a:rPr>
-              <a:t>, achieving a massive </a:t>
-            </a:r>
-            <a:r>
-              <a:rPr b="1" lang="en-US" sz="1050">
-                <a:solidFill>
-                  <a:srgbClr val="1F1F1F"/>
-                </a:solidFill>
-                <a:highlight>
-                  <a:srgbClr val="FFFFFF"/>
-                </a:highlight>
-                <a:latin typeface="Roboto"/>
-                <a:ea typeface="Roboto"/>
-                <a:cs typeface="Roboto"/>
-                <a:sym typeface="Roboto"/>
-              </a:rPr>
-              <a:t>103.6% gain</a:t>
-            </a:r>
-            <a:r>
-              <a:rPr lang="en-US" sz="1050">
-                <a:solidFill>
-                  <a:srgbClr val="1F1F1F"/>
-                </a:solidFill>
-                <a:highlight>
-                  <a:srgbClr val="FFFFFF"/>
-                </a:highlight>
-                <a:latin typeface="Roboto"/>
-                <a:ea typeface="Roboto"/>
-                <a:cs typeface="Roboto"/>
-                <a:sym typeface="Roboto"/>
-              </a:rPr>
-              <a:t>, pushing its IPC from 0.82 to 1.67.</a:t>
-            </a:r>
-            <a:endParaRPr sz="1050">
-              <a:solidFill>
-                <a:srgbClr val="1F1F1F"/>
-              </a:solidFill>
-              <a:highlight>
-                <a:srgbClr val="FFFFFF"/>
-              </a:highlight>
-              <a:latin typeface="Roboto"/>
-              <a:ea typeface="Roboto"/>
-              <a:cs typeface="Roboto"/>
-              <a:sym typeface="Roboto"/>
-            </a:endParaRPr>
-          </a:p>
-          <a:p>
-            <a:pPr indent="-295275" lvl="0" marL="457200" rtl="0" algn="l">
-              <a:lnSpc>
-                <a:spcPct val="115000"/>
-              </a:lnSpc>
-              <a:spcBef>
-                <a:spcPts val="0"/>
-              </a:spcBef>
-              <a:spcAft>
-                <a:spcPts val="0"/>
-              </a:spcAft>
-              <a:buClr>
-                <a:srgbClr val="1F1F1F"/>
-              </a:buClr>
-              <a:buSzPts val="1050"/>
-              <a:buFont typeface="Roboto"/>
-              <a:buChar char="●"/>
-            </a:pPr>
-            <a:r>
-              <a:rPr b="1" lang="en-US" sz="1050">
-                <a:solidFill>
-                  <a:srgbClr val="1F1F1F"/>
-                </a:solidFill>
-                <a:highlight>
-                  <a:srgbClr val="FFFFFF"/>
-                </a:highlight>
-                <a:latin typeface="Roboto"/>
-                <a:ea typeface="Roboto"/>
-                <a:cs typeface="Roboto"/>
-                <a:sym typeface="Roboto"/>
-              </a:rPr>
-              <a:t>Chaotic Workloads:</a:t>
-            </a:r>
-            <a:r>
-              <a:rPr lang="en-US" sz="1050">
-                <a:solidFill>
-                  <a:srgbClr val="1F1F1F"/>
-                </a:solidFill>
-                <a:highlight>
-                  <a:srgbClr val="FFFFFF"/>
-                </a:highlight>
-                <a:latin typeface="Roboto"/>
-                <a:ea typeface="Roboto"/>
-                <a:cs typeface="Roboto"/>
-                <a:sym typeface="Roboto"/>
-              </a:rPr>
-              <a:t> Importantly, on volatile and chaotic traces like </a:t>
-            </a:r>
-            <a:r>
-              <a:rPr lang="en-US" sz="1050">
-                <a:solidFill>
-                  <a:srgbClr val="444746"/>
-                </a:solidFill>
-                <a:highlight>
-                  <a:srgbClr val="DDE3EA"/>
-                </a:highlight>
-                <a:latin typeface="Courier New"/>
-                <a:ea typeface="Courier New"/>
-                <a:cs typeface="Courier New"/>
-                <a:sym typeface="Courier New"/>
-              </a:rPr>
-              <a:t>sjeng</a:t>
-            </a:r>
-            <a:r>
-              <a:rPr b="1" lang="en-US" sz="1050">
-                <a:solidFill>
-                  <a:srgbClr val="1F1F1F"/>
-                </a:solidFill>
-                <a:highlight>
-                  <a:srgbClr val="FFFFFF"/>
-                </a:highlight>
-                <a:latin typeface="Roboto"/>
-                <a:ea typeface="Roboto"/>
-                <a:cs typeface="Roboto"/>
-                <a:sym typeface="Roboto"/>
-              </a:rPr>
-              <a:t> and </a:t>
-            </a:r>
-            <a:r>
-              <a:rPr lang="en-US" sz="1050">
-                <a:solidFill>
-                  <a:srgbClr val="444746"/>
-                </a:solidFill>
-                <a:highlight>
-                  <a:srgbClr val="DDE3EA"/>
-                </a:highlight>
-                <a:latin typeface="Courier New"/>
-                <a:ea typeface="Courier New"/>
-                <a:cs typeface="Courier New"/>
-                <a:sym typeface="Courier New"/>
-              </a:rPr>
-              <a:t>povray</a:t>
-            </a:r>
-            <a:r>
-              <a:rPr lang="en-US" sz="1050">
-                <a:solidFill>
-                  <a:srgbClr val="1F1F1F"/>
-                </a:solidFill>
-                <a:highlight>
-                  <a:srgbClr val="FFFFFF"/>
-                </a:highlight>
-                <a:latin typeface="Roboto"/>
-                <a:ea typeface="Roboto"/>
-                <a:cs typeface="Roboto"/>
-                <a:sym typeface="Roboto"/>
-              </a:rPr>
-              <a:t>, we managed to </a:t>
-            </a:r>
-            <a:r>
-              <a:rPr b="1" lang="en-US" sz="1050">
-                <a:solidFill>
-                  <a:srgbClr val="1F1F1F"/>
-                </a:solidFill>
-                <a:highlight>
-                  <a:srgbClr val="FFFFFF"/>
-                </a:highlight>
-                <a:latin typeface="Roboto"/>
-                <a:ea typeface="Roboto"/>
-                <a:cs typeface="Roboto"/>
-                <a:sym typeface="Roboto"/>
-              </a:rPr>
-              <a:t>hold ground at +0% gain</a:t>
-            </a:r>
-            <a:r>
-              <a:rPr lang="en-US" sz="1050">
-                <a:solidFill>
-                  <a:srgbClr val="1F1F1F"/>
-                </a:solidFill>
-                <a:highlight>
-                  <a:srgbClr val="FFFFFF"/>
-                </a:highlight>
-                <a:latin typeface="Roboto"/>
-                <a:ea typeface="Roboto"/>
-                <a:cs typeface="Roboto"/>
-                <a:sym typeface="Roboto"/>
-              </a:rPr>
-              <a:t>. This demonstrates that our high-confidence policy successfully avoided aggressive, high-confidence mispredictions in unpredictable scenarios, preventing performance degradation</a:t>
-            </a:r>
-            <a:endParaRPr sz="1050">
-              <a:solidFill>
-                <a:srgbClr val="1F1F1F"/>
-              </a:solidFill>
-              <a:highlight>
-                <a:srgbClr val="FFFFFF"/>
-              </a:highlight>
-              <a:latin typeface="Roboto"/>
-              <a:ea typeface="Roboto"/>
-              <a:cs typeface="Roboto"/>
-              <a:sym typeface="Roboto"/>
-            </a:endParaRPr>
-          </a:p>
-          <a:p>
-            <a:pPr indent="0" lvl="0" marL="0" marR="0" rtl="0" algn="l">
-              <a:spcBef>
-                <a:spcPts val="0"/>
-              </a:spcBef>
-              <a:spcAft>
-                <a:spcPts val="0"/>
-              </a:spcAft>
-              <a:buNone/>
-            </a:pPr>
-            <a:r>
-              <a:t/>
-            </a:r>
-            <a:endParaRPr sz="1200">
-              <a:solidFill>
-                <a:schemeClr val="dk1"/>
-              </a:solidFill>
-            </a:endParaRPr>
-          </a:p>
-        </p:txBody>
-      </p:sp>
-      <p:sp>
-        <p:nvSpPr>
-          <p:cNvPr id="208" name="Google Shape;208;p7:notes"/>
-          <p:cNvSpPr txBox="1"/>
-          <p:nvPr>
-            <p:ph idx="12" type="sldNum"/>
-          </p:nvPr>
-        </p:nvSpPr>
-        <p:spPr>
-          <a:xfrm>
-            <a:off x="0" y="0"/>
-            <a:ext cx="3000000" cy="3000000"/>
-          </a:xfrm>
-          <a:prstGeom prst="rect">
-            <a:avLst/>
-          </a:prstGeom>
-          <a:noFill/>
-          <a:ln>
-            <a:noFill/>
-          </a:ln>
-        </p:spPr>
-        <p:txBody>
-          <a:bodyPr anchorCtr="0" anchor="t" bIns="45700" lIns="91425" spcFirstLastPara="1" rIns="91425" wrap="square" tIns="45700">
-            <a:noAutofit/>
-          </a:bodyPr>
-          <a:lstStyle/>
-          <a:p>
-            <a:pPr indent="0" lvl="0" marL="0" marR="0" rtl="0" algn="l">
-              <a:spcBef>
-                <a:spcPts val="0"/>
-              </a:spcBef>
-              <a:spcAft>
-                <a:spcPts val="0"/>
-              </a:spcAft>
-              <a:buNone/>
-            </a:pPr>
-            <a:fld id="{00000000-1234-1234-1234-123412341234}" type="slidenum">
-              <a:rPr lang="en-US" sz="1800">
-                <a:solidFill>
-                  <a:schemeClr val="dk1"/>
-                </a:solidFill>
-                <a:latin typeface="Arial"/>
-                <a:ea typeface="Arial"/>
-                <a:cs typeface="Arial"/>
-                <a:sym typeface="Arial"/>
-              </a:rPr>
-              <a:t>‹#›</a:t>
-            </a:fld>
-            <a:endParaRPr sz="1800">
-              <a:solidFill>
-                <a:schemeClr val="dk1"/>
-              </a:solidFill>
-              <a:latin typeface="Arial"/>
-              <a:ea typeface="Arial"/>
-              <a:cs typeface="Arial"/>
-              <a:sym typeface="Arial"/>
-            </a:endParaRPr>
-          </a:p>
-        </p:txBody>
-      </p:sp>
-    </p:spTree>
-  </p:cSld>
-  <p:clrMapOvr>
-    <a:masterClrMapping/>
-  </p:clrMapOvr>
-</p:notes>
 </file>
 
 <file path=ppt/slideLayouts/slideLayout1.xml><?xml version="1.0" encoding="utf-8"?>
@@ -6822,7 +2708,7 @@
                 <a:cs typeface="Calibri"/>
                 <a:sym typeface="Calibri"/>
               </a:rPr>
-              <a:t>perlbench confident correct predictions skyrocket from 2.24 million (SVP) to 5.28 million. This +135% increase is direct IPC gain. VTAGE successfully maps complex control-flow loops that simple stride math is physically incapable of learning.</a:t>
+              <a:t>perlbench confident correct predictions skyrocket from 2.24 million (SVP) to 5.28 million. This is an approximately 135% increase. VTAGE successfully maps complex control-flow loops that simple stride math is physically incapable of learning.</a:t>
             </a:r>
             <a:endParaRPr sz="1150">
               <a:solidFill>
@@ -7662,7 +3548,7 @@
                 <a:cs typeface="Calibri"/>
                 <a:sym typeface="Calibri"/>
               </a:rPr>
-              <a:t>Key takeaway: conf_max=63 nearly eliminates confident mispredictions on chaotic workloads. Decoupling SVP conf_max to 47 recovers structured workload performance without sacrificing that safety.</a:t>
+              <a:t>Key takeaway: conf_max=63 reduces confident mispredictions on chaotic workloads. Decoupling SVP conf_max to 47 recovers structured workload performance.</a:t>
             </a:r>
             <a:endParaRPr sz="1100">
               <a:solidFill>
@@ -10075,7 +5961,7 @@
                 <a:cs typeface="Calibri"/>
                 <a:sym typeface="Calibri"/>
               </a:rPr>
-              <a:t>Decoupling confidence ceilings was the single most impactful discovery: conf_max=63 for VTAGE eliminates confident mispredictions on chaotic workloads, while conf_max=47 for SVP keeps structured workloads firing aggressively.</a:t>
+              <a:t>Decoupling confidence ceilings was the single most impactful discovery: conf_max=63 for VTAGE reduces confident mispredictions on chaotic workloads, while conf_max=47 for SVP keeps structured workloads firing aggressively.</a:t>
             </a:r>
             <a:endParaRPr sz="1200">
               <a:solidFill>
@@ -12523,7 +8409,7 @@
                 <a:cs typeface="Calibri"/>
                 <a:sym typeface="Calibri"/>
               </a:rPr>
-              <a:t>Each entry stores a predicted value, a confidence counter, and a usefulness bit. An entry only fires when it has proven itself through many consecutive correct predictions. This serves as a high confidence bar that filters noise.</a:t>
+              <a:t>Each entry stores a predicted value, a confidence counter, and a usefulness bit. An entry fires only at full confidence. Probabilistic training builds trust over repeated correct outcomes.</a:t>
             </a:r>
             <a:endParaRPr sz="1100">
               <a:solidFill>
@@ -16586,7 +12472,7 @@
                 <a:cs typeface="Calibri"/>
                 <a:sym typeface="Calibri"/>
               </a:rPr>
-              <a:t>VTAGE entries that have spent 63 correct predictions proving themselves can still be overridden by SVP, wasting that learned state.</a:t>
+              <a:t>Fully confident VTAGE entries can still be overridden by SVP, wasting that learned state.</a:t>
             </a:r>
             <a:endParaRPr sz="1050">
               <a:solidFill>
@@ -16889,7 +12775,7 @@
                 <a:cs typeface="Calibri"/>
                 <a:sym typeface="Calibri"/>
               </a:rPr>
-              <a:t>SVP overrides VTAGE only when VTAGE has NOT yet reached its maximum confidence. Once VTAGE achieves full confidence (63 correct predictions), it wins — its deeply proven pattern takes priority over SVP. SVP can again block allocation regardless of if it wins.  </a:t>
+              <a:t>SVP overrides VTAGE only when VTAGE has NOT yet reached its maximum confidence. Once VTAGE achieves full confidence (counter = 63), it wins. SVP can block allocation regardless of which predictor wins.</a:t>
             </a:r>
             <a:endParaRPr sz="1100">
               <a:solidFill>
@@ -17015,7 +12901,7 @@
                 <a:cs typeface="Calibri"/>
                 <a:sym typeface="Calibri"/>
               </a:rPr>
-              <a:t>A VTAGE entry at conf_max=63 has survived 63+ correct predictions under varying history conditions. This is a stronger proof of correctness than SVP's simpler stride match, especially for complex instructions. Furthermore, VTAGE has a more contextual prediction based on the GBHR. </a:t>
+              <a:t>A fully confident VTAGE entry captures context-dependent value patterns through branch history. Confidence is trained probabilistically, so a counter value of 63 is not a count of 63 observations.</a:t>
             </a:r>
             <a:endParaRPr sz="1100">
               <a:solidFill>
@@ -18919,7 +14805,7 @@
                 <a:cs typeface="Calibri"/>
                 <a:sym typeface="Calibri"/>
               </a:rPr>
-              <a:t>SVP uses 19kb  for stride prediction. Five VTAGE tables use the remaining 13kb or complex history.</a:t>
+              <a:t>SVP and five VTAGE tables share a strict 32 KB storage budget.</a:t>
             </a:r>
             <a:endParaRPr sz="850">
               <a:solidFill>
@@ -21246,7 +17132,7 @@
                 <a:cs typeface="Calibri"/>
                 <a:sym typeface="Calibri"/>
               </a:rPr>
-              <a:t>High confidence bar — entries must prove themselves 63+ times</a:t>
+              <a:t>High confidence bar with probabilistic training</a:t>
             </a:r>
             <a:endParaRPr sz="950">
               <a:solidFill>
@@ -22104,7 +17990,7 @@
                 <a:cs typeface="Calibri"/>
                 <a:sym typeface="Calibri"/>
               </a:rPr>
-              <a:t>Storage Budget: SVP = 19.07 KB  |  VTAGE = 12.97 KB  |  TOTAL = 31.97 KB  ✓ Under 32 KB</a:t>
+              <a:t>Storage Budget: TOTAL = 31.97 KB  |  BUDGET = 32 KB</a:t>
             </a:r>
             <a:endParaRPr sz="1200">
               <a:solidFill>

</xml_diff>